<commit_message>
Power lab 010 terminado
</commit_message>
<xml_diff>
--- a/LabBook_010.pptx
+++ b/LabBook_010.pptx
@@ -5,17 +5,19 @@
     <p:sldMasterId id="2147483648" r:id="rId4"/>
   </p:sldMasterIdLst>
   <p:notesMasterIdLst>
-    <p:notesMasterId r:id="rId10"/>
+    <p:notesMasterId r:id="rId12"/>
   </p:notesMasterIdLst>
   <p:handoutMasterIdLst>
-    <p:handoutMasterId r:id="rId11"/>
+    <p:handoutMasterId r:id="rId13"/>
   </p:handoutMasterIdLst>
   <p:sldIdLst>
     <p:sldId id="256" r:id="rId5"/>
     <p:sldId id="289" r:id="rId6"/>
     <p:sldId id="290" r:id="rId7"/>
-    <p:sldId id="291" r:id="rId8"/>
-    <p:sldId id="288" r:id="rId9"/>
+    <p:sldId id="292" r:id="rId8"/>
+    <p:sldId id="291" r:id="rId9"/>
+    <p:sldId id="293" r:id="rId10"/>
+    <p:sldId id="288" r:id="rId11"/>
   </p:sldIdLst>
   <p:sldSz cx="12192000" cy="6858000"/>
   <p:notesSz cx="12192000" cy="6858000"/>
@@ -238,7 +240,7 @@
           <a:p>
             <a:fld id="{8438F8DC-35B0-48E6-A86E-42F1F08DD00F}" type="datetimeFigureOut">
               <a:rPr lang="es-ES" smtClean="0"/>
-              <a:t>09/02/2026</a:t>
+              <a:t>16/02/2026</a:t>
             </a:fld>
             <a:endParaRPr lang="es-ES"/>
           </a:p>
@@ -415,7 +417,7 @@
           <a:p>
             <a:fld id="{FACBDC12-F39B-4B97-8F4D-6734F9D366FF}" type="datetimeFigureOut">
               <a:rPr lang="es-ES" smtClean="0"/>
-              <a:t>09/02/2026</a:t>
+              <a:t>16/02/2026</a:t>
             </a:fld>
             <a:endParaRPr lang="es-ES"/>
           </a:p>
@@ -855,7 +857,7 @@
           <a:p>
             <a:fld id="{676223B9-C868-4436-87D9-1A3152E1157A}" type="slidenum">
               <a:rPr lang="es-ES" smtClean="0"/>
-              <a:t>4</a:t>
+              <a:t>5</a:t>
             </a:fld>
             <a:endParaRPr lang="es-ES"/>
           </a:p>
@@ -5886,7 +5888,7 @@
         <p:spPr>
           <a:xfrm>
             <a:off x="609441" y="4860334"/>
-            <a:ext cx="11199971" cy="1200329"/>
+            <a:ext cx="11199971" cy="1384995"/>
           </a:xfrm>
           <a:prstGeom prst="rect">
             <a:avLst/>
@@ -5914,40 +5916,343 @@
                 <a:latin typeface="Arial" panose="020B0604020202020204" pitchFamily="34" charset="0"/>
                 <a:cs typeface="Arial" panose="020B0604020202020204" pitchFamily="34" charset="0"/>
               </a:rPr>
-              <a:t>Document all your results (neff, plot fields </a:t>
-            </a:r>
-            <a:r>
-              <a:rPr lang="en-US" sz="1200">
-                <a:latin typeface="Arial" panose="020B0604020202020204" pitchFamily="34" charset="0"/>
-                <a:cs typeface="Arial" panose="020B0604020202020204" pitchFamily="34" charset="0"/>
-              </a:rPr>
-              <a:t>of different modes, </a:t>
+              <a:t>Document all your results (neff, plot fields of different modes, comparison between different polarizations…)</a:t>
+            </a:r>
+          </a:p>
+          <a:p>
+            <a:pPr algn="just"/>
+            <a:r>
+              <a:rPr lang="en-US" sz="1200" dirty="0" err="1">
+                <a:latin typeface="Arial" panose="020B0604020202020204" pitchFamily="34" charset="0"/>
+                <a:cs typeface="Arial" panose="020B0604020202020204" pitchFamily="34" charset="0"/>
+              </a:rPr>
+              <a:t>Tenemos</a:t>
             </a:r>
             <a:r>
               <a:rPr lang="en-US" sz="1200" dirty="0">
                 <a:latin typeface="Arial" panose="020B0604020202020204" pitchFamily="34" charset="0"/>
                 <a:cs typeface="Arial" panose="020B0604020202020204" pitchFamily="34" charset="0"/>
               </a:rPr>
-              <a:t>comparison between </a:t>
-            </a:r>
-            <a:r>
-              <a:rPr lang="en-US" sz="1200">
-                <a:latin typeface="Arial" panose="020B0604020202020204" pitchFamily="34" charset="0"/>
-                <a:cs typeface="Arial" panose="020B0604020202020204" pitchFamily="34" charset="0"/>
-              </a:rPr>
-              <a:t>different polarizations…)</a:t>
-            </a:r>
-            <a:endParaRPr lang="en-US" sz="1200" dirty="0">
-              <a:latin typeface="Arial" panose="020B0604020202020204" pitchFamily="34" charset="0"/>
-              <a:cs typeface="Arial" panose="020B0604020202020204" pitchFamily="34" charset="0"/>
-            </a:endParaRPr>
+              <a:t> 4 </a:t>
+            </a:r>
+            <a:r>
+              <a:rPr lang="en-US" sz="1200" dirty="0" err="1">
+                <a:latin typeface="Arial" panose="020B0604020202020204" pitchFamily="34" charset="0"/>
+                <a:cs typeface="Arial" panose="020B0604020202020204" pitchFamily="34" charset="0"/>
+              </a:rPr>
+              <a:t>modos</a:t>
+            </a:r>
+            <a:r>
+              <a:rPr lang="en-US" sz="1200" dirty="0">
+                <a:latin typeface="Arial" panose="020B0604020202020204" pitchFamily="34" charset="0"/>
+                <a:cs typeface="Arial" panose="020B0604020202020204" pitchFamily="34" charset="0"/>
+              </a:rPr>
+              <a:t> </a:t>
+            </a:r>
+            <a:r>
+              <a:rPr lang="en-US" sz="1200" dirty="0" err="1">
+                <a:latin typeface="Arial" panose="020B0604020202020204" pitchFamily="34" charset="0"/>
+                <a:cs typeface="Arial" panose="020B0604020202020204" pitchFamily="34" charset="0"/>
+              </a:rPr>
+              <a:t>que</a:t>
+            </a:r>
+            <a:r>
+              <a:rPr lang="en-US" sz="1200" dirty="0">
+                <a:latin typeface="Arial" panose="020B0604020202020204" pitchFamily="34" charset="0"/>
+                <a:cs typeface="Arial" panose="020B0604020202020204" pitchFamily="34" charset="0"/>
+              </a:rPr>
+              <a:t> se </a:t>
+            </a:r>
+            <a:r>
+              <a:rPr lang="en-US" sz="1200" dirty="0" err="1">
+                <a:latin typeface="Arial" panose="020B0604020202020204" pitchFamily="34" charset="0"/>
+                <a:cs typeface="Arial" panose="020B0604020202020204" pitchFamily="34" charset="0"/>
+              </a:rPr>
+              <a:t>propagan</a:t>
+            </a:r>
+            <a:r>
+              <a:rPr lang="en-US" sz="1200" dirty="0">
+                <a:latin typeface="Arial" panose="020B0604020202020204" pitchFamily="34" charset="0"/>
+                <a:cs typeface="Arial" panose="020B0604020202020204" pitchFamily="34" charset="0"/>
+              </a:rPr>
+              <a:t>: </a:t>
+            </a:r>
+            <a:r>
+              <a:rPr lang="en-US" sz="1200" dirty="0" err="1">
+                <a:latin typeface="Arial" panose="020B0604020202020204" pitchFamily="34" charset="0"/>
+                <a:cs typeface="Arial" panose="020B0604020202020204" pitchFamily="34" charset="0"/>
+              </a:rPr>
+              <a:t>los</a:t>
+            </a:r>
+            <a:r>
+              <a:rPr lang="en-US" sz="1200" dirty="0">
+                <a:latin typeface="Arial" panose="020B0604020202020204" pitchFamily="34" charset="0"/>
+                <a:cs typeface="Arial" panose="020B0604020202020204" pitchFamily="34" charset="0"/>
+              </a:rPr>
+              <a:t> </a:t>
+            </a:r>
+            <a:r>
+              <a:rPr lang="en-US" sz="1200" dirty="0" err="1">
+                <a:latin typeface="Arial" panose="020B0604020202020204" pitchFamily="34" charset="0"/>
+                <a:cs typeface="Arial" panose="020B0604020202020204" pitchFamily="34" charset="0"/>
+              </a:rPr>
+              <a:t>modos</a:t>
+            </a:r>
+            <a:r>
+              <a:rPr lang="en-US" sz="1200" dirty="0">
+                <a:latin typeface="Arial" panose="020B0604020202020204" pitchFamily="34" charset="0"/>
+                <a:cs typeface="Arial" panose="020B0604020202020204" pitchFamily="34" charset="0"/>
+              </a:rPr>
+              <a:t> 0 y 2 son </a:t>
+            </a:r>
+            <a:r>
+              <a:rPr lang="en-US" sz="1200" dirty="0" err="1">
+                <a:latin typeface="Arial" panose="020B0604020202020204" pitchFamily="34" charset="0"/>
+                <a:cs typeface="Arial" panose="020B0604020202020204" pitchFamily="34" charset="0"/>
+              </a:rPr>
+              <a:t>modos</a:t>
+            </a:r>
+            <a:r>
+              <a:rPr lang="en-US" sz="1200" dirty="0">
+                <a:latin typeface="Arial" panose="020B0604020202020204" pitchFamily="34" charset="0"/>
+                <a:cs typeface="Arial" panose="020B0604020202020204" pitchFamily="34" charset="0"/>
+              </a:rPr>
+              <a:t> TE y </a:t>
+            </a:r>
+            <a:r>
+              <a:rPr lang="en-US" sz="1200" dirty="0" err="1">
+                <a:latin typeface="Arial" panose="020B0604020202020204" pitchFamily="34" charset="0"/>
+                <a:cs typeface="Arial" panose="020B0604020202020204" pitchFamily="34" charset="0"/>
+              </a:rPr>
+              <a:t>los</a:t>
+            </a:r>
+            <a:r>
+              <a:rPr lang="en-US" sz="1200" dirty="0">
+                <a:latin typeface="Arial" panose="020B0604020202020204" pitchFamily="34" charset="0"/>
+                <a:cs typeface="Arial" panose="020B0604020202020204" pitchFamily="34" charset="0"/>
+              </a:rPr>
+              <a:t> </a:t>
+            </a:r>
+            <a:r>
+              <a:rPr lang="en-US" sz="1200" dirty="0" err="1">
+                <a:latin typeface="Arial" panose="020B0604020202020204" pitchFamily="34" charset="0"/>
+                <a:cs typeface="Arial" panose="020B0604020202020204" pitchFamily="34" charset="0"/>
+              </a:rPr>
+              <a:t>modos</a:t>
+            </a:r>
+            <a:r>
+              <a:rPr lang="en-US" sz="1200" dirty="0">
+                <a:latin typeface="Arial" panose="020B0604020202020204" pitchFamily="34" charset="0"/>
+                <a:cs typeface="Arial" panose="020B0604020202020204" pitchFamily="34" charset="0"/>
+              </a:rPr>
+              <a:t> 1 y 3 son TM.</a:t>
+            </a:r>
           </a:p>
           <a:p>
             <a:pPr algn="just"/>
-            <a:endParaRPr lang="en-US" sz="1200" dirty="0">
-              <a:latin typeface="Arial" panose="020B0604020202020204" pitchFamily="34" charset="0"/>
-              <a:cs typeface="Arial" panose="020B0604020202020204" pitchFamily="34" charset="0"/>
-            </a:endParaRPr>
+            <a:r>
+              <a:rPr lang="en-US" sz="1200" dirty="0">
+                <a:latin typeface="Arial" panose="020B0604020202020204" pitchFamily="34" charset="0"/>
+                <a:cs typeface="Arial" panose="020B0604020202020204" pitchFamily="34" charset="0"/>
+              </a:rPr>
+              <a:t>Se </a:t>
+            </a:r>
+            <a:r>
+              <a:rPr lang="en-US" sz="1200" dirty="0" err="1">
+                <a:latin typeface="Arial" panose="020B0604020202020204" pitchFamily="34" charset="0"/>
+                <a:cs typeface="Arial" panose="020B0604020202020204" pitchFamily="34" charset="0"/>
+              </a:rPr>
+              <a:t>puede</a:t>
+            </a:r>
+            <a:r>
+              <a:rPr lang="en-US" sz="1200" dirty="0">
+                <a:latin typeface="Arial" panose="020B0604020202020204" pitchFamily="34" charset="0"/>
+                <a:cs typeface="Arial" panose="020B0604020202020204" pitchFamily="34" charset="0"/>
+              </a:rPr>
+              <a:t> </a:t>
+            </a:r>
+            <a:r>
+              <a:rPr lang="en-US" sz="1200" dirty="0" err="1">
+                <a:latin typeface="Arial" panose="020B0604020202020204" pitchFamily="34" charset="0"/>
+                <a:cs typeface="Arial" panose="020B0604020202020204" pitchFamily="34" charset="0"/>
+              </a:rPr>
+              <a:t>observar</a:t>
+            </a:r>
+            <a:r>
+              <a:rPr lang="en-US" sz="1200" dirty="0">
+                <a:latin typeface="Arial" panose="020B0604020202020204" pitchFamily="34" charset="0"/>
+                <a:cs typeface="Arial" panose="020B0604020202020204" pitchFamily="34" charset="0"/>
+              </a:rPr>
+              <a:t> </a:t>
+            </a:r>
+            <a:r>
+              <a:rPr lang="en-US" sz="1200" dirty="0" err="1">
+                <a:latin typeface="Arial" panose="020B0604020202020204" pitchFamily="34" charset="0"/>
+                <a:cs typeface="Arial" panose="020B0604020202020204" pitchFamily="34" charset="0"/>
+              </a:rPr>
+              <a:t>en</a:t>
+            </a:r>
+            <a:r>
+              <a:rPr lang="en-US" sz="1200" dirty="0">
+                <a:latin typeface="Arial" panose="020B0604020202020204" pitchFamily="34" charset="0"/>
+                <a:cs typeface="Arial" panose="020B0604020202020204" pitchFamily="34" charset="0"/>
+              </a:rPr>
+              <a:t> </a:t>
+            </a:r>
+            <a:r>
+              <a:rPr lang="en-US" sz="1200" dirty="0" err="1">
+                <a:latin typeface="Arial" panose="020B0604020202020204" pitchFamily="34" charset="0"/>
+                <a:cs typeface="Arial" panose="020B0604020202020204" pitchFamily="34" charset="0"/>
+              </a:rPr>
+              <a:t>los</a:t>
+            </a:r>
+            <a:r>
+              <a:rPr lang="en-US" sz="1200" dirty="0">
+                <a:latin typeface="Arial" panose="020B0604020202020204" pitchFamily="34" charset="0"/>
+                <a:cs typeface="Arial" panose="020B0604020202020204" pitchFamily="34" charset="0"/>
+              </a:rPr>
+              <a:t> plots </a:t>
+            </a:r>
+            <a:r>
+              <a:rPr lang="en-US" sz="1200" dirty="0" err="1">
+                <a:latin typeface="Arial" panose="020B0604020202020204" pitchFamily="34" charset="0"/>
+                <a:cs typeface="Arial" panose="020B0604020202020204" pitchFamily="34" charset="0"/>
+              </a:rPr>
+              <a:t>que</a:t>
+            </a:r>
+            <a:r>
+              <a:rPr lang="en-US" sz="1200" dirty="0">
+                <a:latin typeface="Arial" panose="020B0604020202020204" pitchFamily="34" charset="0"/>
+                <a:cs typeface="Arial" panose="020B0604020202020204" pitchFamily="34" charset="0"/>
+              </a:rPr>
+              <a:t> </a:t>
+            </a:r>
+            <a:r>
+              <a:rPr lang="en-US" sz="1200" dirty="0" err="1">
+                <a:latin typeface="Arial" panose="020B0604020202020204" pitchFamily="34" charset="0"/>
+                <a:cs typeface="Arial" panose="020B0604020202020204" pitchFamily="34" charset="0"/>
+              </a:rPr>
+              <a:t>el</a:t>
+            </a:r>
+            <a:r>
+              <a:rPr lang="en-US" sz="1200" dirty="0">
+                <a:latin typeface="Arial" panose="020B0604020202020204" pitchFamily="34" charset="0"/>
+                <a:cs typeface="Arial" panose="020B0604020202020204" pitchFamily="34" charset="0"/>
+              </a:rPr>
+              <a:t> campo </a:t>
+            </a:r>
+            <a:r>
+              <a:rPr lang="en-US" sz="1200" dirty="0" err="1">
+                <a:latin typeface="Arial" panose="020B0604020202020204" pitchFamily="34" charset="0"/>
+                <a:cs typeface="Arial" panose="020B0604020202020204" pitchFamily="34" charset="0"/>
+              </a:rPr>
+              <a:t>en</a:t>
+            </a:r>
+            <a:r>
+              <a:rPr lang="en-US" sz="1200" dirty="0">
+                <a:latin typeface="Arial" panose="020B0604020202020204" pitchFamily="34" charset="0"/>
+                <a:cs typeface="Arial" panose="020B0604020202020204" pitchFamily="34" charset="0"/>
+              </a:rPr>
+              <a:t> </a:t>
+            </a:r>
+            <a:r>
+              <a:rPr lang="en-US" sz="1200" dirty="0" err="1">
+                <a:latin typeface="Arial" panose="020B0604020202020204" pitchFamily="34" charset="0"/>
+                <a:cs typeface="Arial" panose="020B0604020202020204" pitchFamily="34" charset="0"/>
+              </a:rPr>
+              <a:t>los</a:t>
+            </a:r>
+            <a:r>
+              <a:rPr lang="en-US" sz="1200" dirty="0">
+                <a:latin typeface="Arial" panose="020B0604020202020204" pitchFamily="34" charset="0"/>
+                <a:cs typeface="Arial" panose="020B0604020202020204" pitchFamily="34" charset="0"/>
+              </a:rPr>
+              <a:t> </a:t>
+            </a:r>
+            <a:r>
+              <a:rPr lang="en-US" sz="1200" dirty="0" err="1">
+                <a:latin typeface="Arial" panose="020B0604020202020204" pitchFamily="34" charset="0"/>
+                <a:cs typeface="Arial" panose="020B0604020202020204" pitchFamily="34" charset="0"/>
+              </a:rPr>
+              <a:t>modos</a:t>
+            </a:r>
+            <a:r>
+              <a:rPr lang="en-US" sz="1200" dirty="0">
+                <a:latin typeface="Arial" panose="020B0604020202020204" pitchFamily="34" charset="0"/>
+                <a:cs typeface="Arial" panose="020B0604020202020204" pitchFamily="34" charset="0"/>
+              </a:rPr>
+              <a:t> 0 (TE) y 1 (TM) </a:t>
+            </a:r>
+            <a:r>
+              <a:rPr lang="en-US" sz="1200" dirty="0" err="1">
+                <a:latin typeface="Arial" panose="020B0604020202020204" pitchFamily="34" charset="0"/>
+                <a:cs typeface="Arial" panose="020B0604020202020204" pitchFamily="34" charset="0"/>
+              </a:rPr>
+              <a:t>estan</a:t>
+            </a:r>
+            <a:r>
+              <a:rPr lang="en-US" sz="1200" dirty="0">
+                <a:latin typeface="Arial" panose="020B0604020202020204" pitchFamily="34" charset="0"/>
+                <a:cs typeface="Arial" panose="020B0604020202020204" pitchFamily="34" charset="0"/>
+              </a:rPr>
+              <a:t> </a:t>
+            </a:r>
+            <a:r>
+              <a:rPr lang="en-US" sz="1200" dirty="0" err="1">
+                <a:latin typeface="Arial" panose="020B0604020202020204" pitchFamily="34" charset="0"/>
+                <a:cs typeface="Arial" panose="020B0604020202020204" pitchFamily="34" charset="0"/>
+              </a:rPr>
+              <a:t>confinados</a:t>
+            </a:r>
+            <a:r>
+              <a:rPr lang="en-US" sz="1200" dirty="0">
+                <a:latin typeface="Arial" panose="020B0604020202020204" pitchFamily="34" charset="0"/>
+                <a:cs typeface="Arial" panose="020B0604020202020204" pitchFamily="34" charset="0"/>
+              </a:rPr>
+              <a:t> a </a:t>
+            </a:r>
+            <a:r>
+              <a:rPr lang="en-US" sz="1200" dirty="0" err="1">
+                <a:latin typeface="Arial" panose="020B0604020202020204" pitchFamily="34" charset="0"/>
+                <a:cs typeface="Arial" panose="020B0604020202020204" pitchFamily="34" charset="0"/>
+              </a:rPr>
+              <a:t>difernecia</a:t>
+            </a:r>
+            <a:r>
+              <a:rPr lang="en-US" sz="1200" dirty="0">
+                <a:latin typeface="Arial" panose="020B0604020202020204" pitchFamily="34" charset="0"/>
+                <a:cs typeface="Arial" panose="020B0604020202020204" pitchFamily="34" charset="0"/>
+              </a:rPr>
+              <a:t> de </a:t>
+            </a:r>
+            <a:r>
+              <a:rPr lang="en-US" sz="1200" dirty="0" err="1">
+                <a:latin typeface="Arial" panose="020B0604020202020204" pitchFamily="34" charset="0"/>
+                <a:cs typeface="Arial" panose="020B0604020202020204" pitchFamily="34" charset="0"/>
+              </a:rPr>
+              <a:t>los</a:t>
+            </a:r>
+            <a:r>
+              <a:rPr lang="en-US" sz="1200" dirty="0">
+                <a:latin typeface="Arial" panose="020B0604020202020204" pitchFamily="34" charset="0"/>
+                <a:cs typeface="Arial" panose="020B0604020202020204" pitchFamily="34" charset="0"/>
+              </a:rPr>
+              <a:t> </a:t>
+            </a:r>
+            <a:r>
+              <a:rPr lang="en-US" sz="1200" dirty="0" err="1">
+                <a:latin typeface="Arial" panose="020B0604020202020204" pitchFamily="34" charset="0"/>
+                <a:cs typeface="Arial" panose="020B0604020202020204" pitchFamily="34" charset="0"/>
+              </a:rPr>
+              <a:t>modos</a:t>
+            </a:r>
+            <a:r>
+              <a:rPr lang="en-US" sz="1200" dirty="0">
+                <a:latin typeface="Arial" panose="020B0604020202020204" pitchFamily="34" charset="0"/>
+                <a:cs typeface="Arial" panose="020B0604020202020204" pitchFamily="34" charset="0"/>
+              </a:rPr>
+              <a:t> 2 (TE) y 3 (TM).</a:t>
+            </a:r>
           </a:p>
           <a:p>
             <a:pPr algn="just"/>
@@ -5993,6 +6298,806 @@
 </file>
 
 <file path=ppt/slides/slide4.xml><?xml version="1.0" encoding="utf-8"?>
+<p:sld xmlns:a="http://schemas.openxmlformats.org/drawingml/2006/main" xmlns:r="http://schemas.openxmlformats.org/officeDocument/2006/relationships" xmlns:p="http://schemas.openxmlformats.org/presentationml/2006/main">
+  <p:cSld>
+    <p:spTree>
+      <p:nvGrpSpPr>
+        <p:cNvPr id="1" name=""/>
+        <p:cNvGrpSpPr/>
+        <p:nvPr/>
+      </p:nvGrpSpPr>
+      <p:grpSpPr>
+        <a:xfrm>
+          <a:off x="0" y="0"/>
+          <a:ext cx="0" cy="0"/>
+          <a:chOff x="0" y="0"/>
+          <a:chExt cx="0" cy="0"/>
+        </a:xfrm>
+      </p:grpSpPr>
+      <p:sp>
+        <p:nvSpPr>
+          <p:cNvPr id="2" name="Título 1">
+            <a:extLst>
+              <a:ext uri="{FF2B5EF4-FFF2-40B4-BE49-F238E27FC236}">
+                <a16:creationId xmlns:a16="http://schemas.microsoft.com/office/drawing/2014/main" id="{5F9E763E-BC09-F2D2-5B5F-BA40B7820425}"/>
+              </a:ext>
+            </a:extLst>
+          </p:cNvPr>
+          <p:cNvSpPr>
+            <a:spLocks noGrp="1"/>
+          </p:cNvSpPr>
+          <p:nvPr>
+            <p:ph type="title"/>
+          </p:nvPr>
+        </p:nvSpPr>
+        <p:spPr/>
+        <p:txBody>
+          <a:bodyPr/>
+          <a:lstStyle/>
+          <a:p>
+            <a:r>
+              <a:rPr lang="es-ES" dirty="0"/>
+              <a:t>Comentario resultados obtenidos</a:t>
+            </a:r>
+          </a:p>
+        </p:txBody>
+      </p:sp>
+      <p:sp>
+        <p:nvSpPr>
+          <p:cNvPr id="3" name="Marcador de texto 2">
+            <a:extLst>
+              <a:ext uri="{FF2B5EF4-FFF2-40B4-BE49-F238E27FC236}">
+                <a16:creationId xmlns:a16="http://schemas.microsoft.com/office/drawing/2014/main" id="{88D9BAE8-7464-7A8D-1505-101CD955D4A9}"/>
+              </a:ext>
+            </a:extLst>
+          </p:cNvPr>
+          <p:cNvSpPr>
+            <a:spLocks noGrp="1"/>
+          </p:cNvSpPr>
+          <p:nvPr>
+            <p:ph type="body" idx="1"/>
+          </p:nvPr>
+        </p:nvSpPr>
+        <p:spPr>
+          <a:xfrm>
+            <a:off x="543897" y="667952"/>
+            <a:ext cx="3991341" cy="646331"/>
+          </a:xfrm>
+        </p:spPr>
+        <p:txBody>
+          <a:bodyPr/>
+          <a:lstStyle/>
+          <a:p>
+            <a:pPr algn="just"/>
+            <a:r>
+              <a:rPr lang="en-US" sz="1400" dirty="0" err="1">
+                <a:latin typeface="Arial" panose="020B0604020202020204" pitchFamily="34" charset="0"/>
+                <a:cs typeface="Arial" panose="020B0604020202020204" pitchFamily="34" charset="0"/>
+              </a:rPr>
+              <a:t>Tenemos</a:t>
+            </a:r>
+            <a:r>
+              <a:rPr lang="en-US" sz="1400" dirty="0">
+                <a:latin typeface="Arial" panose="020B0604020202020204" pitchFamily="34" charset="0"/>
+                <a:cs typeface="Arial" panose="020B0604020202020204" pitchFamily="34" charset="0"/>
+              </a:rPr>
+              <a:t> 4 </a:t>
+            </a:r>
+            <a:r>
+              <a:rPr lang="en-US" sz="1400" dirty="0" err="1">
+                <a:latin typeface="Arial" panose="020B0604020202020204" pitchFamily="34" charset="0"/>
+                <a:cs typeface="Arial" panose="020B0604020202020204" pitchFamily="34" charset="0"/>
+              </a:rPr>
+              <a:t>modos</a:t>
+            </a:r>
+            <a:r>
+              <a:rPr lang="en-US" sz="1400" dirty="0">
+                <a:latin typeface="Arial" panose="020B0604020202020204" pitchFamily="34" charset="0"/>
+                <a:cs typeface="Arial" panose="020B0604020202020204" pitchFamily="34" charset="0"/>
+              </a:rPr>
+              <a:t> </a:t>
+            </a:r>
+            <a:r>
+              <a:rPr lang="en-US" sz="1400" dirty="0" err="1">
+                <a:latin typeface="Arial" panose="020B0604020202020204" pitchFamily="34" charset="0"/>
+                <a:cs typeface="Arial" panose="020B0604020202020204" pitchFamily="34" charset="0"/>
+              </a:rPr>
+              <a:t>que</a:t>
+            </a:r>
+            <a:r>
+              <a:rPr lang="en-US" sz="1400" dirty="0">
+                <a:latin typeface="Arial" panose="020B0604020202020204" pitchFamily="34" charset="0"/>
+                <a:cs typeface="Arial" panose="020B0604020202020204" pitchFamily="34" charset="0"/>
+              </a:rPr>
+              <a:t> se </a:t>
+            </a:r>
+            <a:r>
+              <a:rPr lang="en-US" sz="1400" dirty="0" err="1">
+                <a:latin typeface="Arial" panose="020B0604020202020204" pitchFamily="34" charset="0"/>
+                <a:cs typeface="Arial" panose="020B0604020202020204" pitchFamily="34" charset="0"/>
+              </a:rPr>
+              <a:t>propagan</a:t>
+            </a:r>
+            <a:r>
+              <a:rPr lang="en-US" sz="1400" dirty="0">
+                <a:latin typeface="Arial" panose="020B0604020202020204" pitchFamily="34" charset="0"/>
+                <a:cs typeface="Arial" panose="020B0604020202020204" pitchFamily="34" charset="0"/>
+              </a:rPr>
+              <a:t>: </a:t>
+            </a:r>
+            <a:r>
+              <a:rPr lang="en-US" sz="1400" dirty="0" err="1">
+                <a:latin typeface="Arial" panose="020B0604020202020204" pitchFamily="34" charset="0"/>
+                <a:cs typeface="Arial" panose="020B0604020202020204" pitchFamily="34" charset="0"/>
+              </a:rPr>
+              <a:t>los</a:t>
+            </a:r>
+            <a:r>
+              <a:rPr lang="en-US" sz="1400" dirty="0">
+                <a:latin typeface="Arial" panose="020B0604020202020204" pitchFamily="34" charset="0"/>
+                <a:cs typeface="Arial" panose="020B0604020202020204" pitchFamily="34" charset="0"/>
+              </a:rPr>
+              <a:t> </a:t>
+            </a:r>
+            <a:r>
+              <a:rPr lang="en-US" sz="1400" dirty="0" err="1">
+                <a:latin typeface="Arial" panose="020B0604020202020204" pitchFamily="34" charset="0"/>
+                <a:cs typeface="Arial" panose="020B0604020202020204" pitchFamily="34" charset="0"/>
+              </a:rPr>
+              <a:t>modos</a:t>
+            </a:r>
+            <a:r>
+              <a:rPr lang="en-US" sz="1400" dirty="0">
+                <a:latin typeface="Arial" panose="020B0604020202020204" pitchFamily="34" charset="0"/>
+                <a:cs typeface="Arial" panose="020B0604020202020204" pitchFamily="34" charset="0"/>
+              </a:rPr>
+              <a:t> 0 y 2 son </a:t>
+            </a:r>
+            <a:r>
+              <a:rPr lang="en-US" sz="1400" dirty="0" err="1">
+                <a:latin typeface="Arial" panose="020B0604020202020204" pitchFamily="34" charset="0"/>
+                <a:cs typeface="Arial" panose="020B0604020202020204" pitchFamily="34" charset="0"/>
+              </a:rPr>
+              <a:t>modos</a:t>
+            </a:r>
+            <a:r>
+              <a:rPr lang="en-US" sz="1400" dirty="0">
+                <a:latin typeface="Arial" panose="020B0604020202020204" pitchFamily="34" charset="0"/>
+                <a:cs typeface="Arial" panose="020B0604020202020204" pitchFamily="34" charset="0"/>
+              </a:rPr>
+              <a:t> TE y </a:t>
+            </a:r>
+            <a:r>
+              <a:rPr lang="en-US" sz="1400" dirty="0" err="1">
+                <a:latin typeface="Arial" panose="020B0604020202020204" pitchFamily="34" charset="0"/>
+                <a:cs typeface="Arial" panose="020B0604020202020204" pitchFamily="34" charset="0"/>
+              </a:rPr>
+              <a:t>los</a:t>
+            </a:r>
+            <a:r>
+              <a:rPr lang="en-US" sz="1400" dirty="0">
+                <a:latin typeface="Arial" panose="020B0604020202020204" pitchFamily="34" charset="0"/>
+                <a:cs typeface="Arial" panose="020B0604020202020204" pitchFamily="34" charset="0"/>
+              </a:rPr>
+              <a:t> </a:t>
+            </a:r>
+            <a:r>
+              <a:rPr lang="en-US" sz="1400" dirty="0" err="1">
+                <a:latin typeface="Arial" panose="020B0604020202020204" pitchFamily="34" charset="0"/>
+                <a:cs typeface="Arial" panose="020B0604020202020204" pitchFamily="34" charset="0"/>
+              </a:rPr>
+              <a:t>modos</a:t>
+            </a:r>
+            <a:r>
+              <a:rPr lang="en-US" sz="1400" dirty="0">
+                <a:latin typeface="Arial" panose="020B0604020202020204" pitchFamily="34" charset="0"/>
+                <a:cs typeface="Arial" panose="020B0604020202020204" pitchFamily="34" charset="0"/>
+              </a:rPr>
+              <a:t> 1 y 3 son TM.</a:t>
+            </a:r>
+          </a:p>
+          <a:p>
+            <a:endParaRPr lang="es-ES" sz="1400" dirty="0"/>
+          </a:p>
+        </p:txBody>
+      </p:sp>
+      <p:sp>
+        <p:nvSpPr>
+          <p:cNvPr id="4" name="Marcador de pie de página 3">
+            <a:extLst>
+              <a:ext uri="{FF2B5EF4-FFF2-40B4-BE49-F238E27FC236}">
+                <a16:creationId xmlns:a16="http://schemas.microsoft.com/office/drawing/2014/main" id="{F050BDDD-47A2-CCA3-6DFC-17F74A4D8525}"/>
+              </a:ext>
+            </a:extLst>
+          </p:cNvPr>
+          <p:cNvSpPr>
+            <a:spLocks noGrp="1"/>
+          </p:cNvSpPr>
+          <p:nvPr>
+            <p:ph type="ftr" sz="quarter" idx="5"/>
+          </p:nvPr>
+        </p:nvSpPr>
+        <p:spPr/>
+        <p:txBody>
+          <a:bodyPr/>
+          <a:lstStyle/>
+          <a:p>
+            <a:pPr marL="12700">
+              <a:spcBef>
+                <a:spcPts val="15"/>
+              </a:spcBef>
+            </a:pPr>
+            <a:r>
+              <a:rPr lang="es-ES" spc="-5"/>
+              <a:t>LAB 0.1. MODESOLVER</a:t>
+            </a:r>
+            <a:endParaRPr lang="es-ES" spc="-5" dirty="0"/>
+          </a:p>
+        </p:txBody>
+      </p:sp>
+      <p:sp>
+        <p:nvSpPr>
+          <p:cNvPr id="5" name="Marcador de número de diapositiva 4">
+            <a:extLst>
+              <a:ext uri="{FF2B5EF4-FFF2-40B4-BE49-F238E27FC236}">
+                <a16:creationId xmlns:a16="http://schemas.microsoft.com/office/drawing/2014/main" id="{000B7220-4CEE-6025-7B44-69AD7E721AE8}"/>
+              </a:ext>
+            </a:extLst>
+          </p:cNvPr>
+          <p:cNvSpPr>
+            <a:spLocks noGrp="1"/>
+          </p:cNvSpPr>
+          <p:nvPr>
+            <p:ph type="sldNum" sz="quarter" idx="7"/>
+          </p:nvPr>
+        </p:nvSpPr>
+        <p:spPr/>
+        <p:txBody>
+          <a:bodyPr/>
+          <a:lstStyle/>
+          <a:p>
+            <a:fld id="{B6F15528-21DE-4FAA-801E-634DDDAF4B2B}" type="slidenum">
+              <a:rPr lang="es-ES" smtClean="0"/>
+              <a:t>4</a:t>
+            </a:fld>
+            <a:endParaRPr lang="es-ES"/>
+          </a:p>
+        </p:txBody>
+      </p:sp>
+      <p:pic>
+        <p:nvPicPr>
+          <p:cNvPr id="7" name="Imagen 6" descr="Interfaz de usuario gráfica, Texto&#10;&#10;El contenido generado por IA puede ser incorrecto.">
+            <a:extLst>
+              <a:ext uri="{FF2B5EF4-FFF2-40B4-BE49-F238E27FC236}">
+                <a16:creationId xmlns:a16="http://schemas.microsoft.com/office/drawing/2014/main" id="{D0052FFC-265F-BD00-A1F5-79369E296432}"/>
+              </a:ext>
+            </a:extLst>
+          </p:cNvPr>
+          <p:cNvPicPr>
+            <a:picLocks noChangeAspect="1"/>
+          </p:cNvPicPr>
+          <p:nvPr/>
+        </p:nvPicPr>
+        <p:blipFill>
+          <a:blip r:embed="rId2"/>
+          <a:stretch>
+            <a:fillRect/>
+          </a:stretch>
+        </p:blipFill>
+        <p:spPr>
+          <a:xfrm>
+            <a:off x="701979" y="1451633"/>
+            <a:ext cx="3448050" cy="1736563"/>
+          </a:xfrm>
+          <a:prstGeom prst="rect">
+            <a:avLst/>
+          </a:prstGeom>
+        </p:spPr>
+      </p:pic>
+      <p:sp>
+        <p:nvSpPr>
+          <p:cNvPr id="8" name="Marcador de texto 2">
+            <a:extLst>
+              <a:ext uri="{FF2B5EF4-FFF2-40B4-BE49-F238E27FC236}">
+                <a16:creationId xmlns:a16="http://schemas.microsoft.com/office/drawing/2014/main" id="{AE70B213-9763-4DA9-8BF3-C01D20E65E05}"/>
+              </a:ext>
+            </a:extLst>
+          </p:cNvPr>
+          <p:cNvSpPr txBox="1">
+            <a:spLocks/>
+          </p:cNvSpPr>
+          <p:nvPr/>
+        </p:nvSpPr>
+        <p:spPr>
+          <a:xfrm>
+            <a:off x="5257800" y="548287"/>
+            <a:ext cx="6553200" cy="1292662"/>
+          </a:xfrm>
+          <a:prstGeom prst="rect">
+            <a:avLst/>
+          </a:prstGeom>
+        </p:spPr>
+        <p:txBody>
+          <a:bodyPr wrap="square" lIns="0" tIns="0" rIns="0" bIns="0">
+            <a:spAutoFit/>
+          </a:bodyPr>
+          <a:lstStyle>
+            <a:lvl1pPr marL="0">
+              <a:defRPr>
+                <a:latin typeface="+mn-lt"/>
+                <a:ea typeface="+mn-ea"/>
+                <a:cs typeface="+mn-cs"/>
+              </a:defRPr>
+            </a:lvl1pPr>
+            <a:lvl2pPr marL="457200">
+              <a:defRPr>
+                <a:latin typeface="+mn-lt"/>
+                <a:ea typeface="+mn-ea"/>
+                <a:cs typeface="+mn-cs"/>
+              </a:defRPr>
+            </a:lvl2pPr>
+            <a:lvl3pPr marL="914400">
+              <a:defRPr>
+                <a:latin typeface="+mn-lt"/>
+                <a:ea typeface="+mn-ea"/>
+                <a:cs typeface="+mn-cs"/>
+              </a:defRPr>
+            </a:lvl3pPr>
+            <a:lvl4pPr marL="1371600">
+              <a:defRPr>
+                <a:latin typeface="+mn-lt"/>
+                <a:ea typeface="+mn-ea"/>
+                <a:cs typeface="+mn-cs"/>
+              </a:defRPr>
+            </a:lvl4pPr>
+            <a:lvl5pPr marL="1828800">
+              <a:defRPr>
+                <a:latin typeface="+mn-lt"/>
+                <a:ea typeface="+mn-ea"/>
+                <a:cs typeface="+mn-cs"/>
+              </a:defRPr>
+            </a:lvl5pPr>
+            <a:lvl6pPr marL="2286000">
+              <a:defRPr>
+                <a:latin typeface="+mn-lt"/>
+                <a:ea typeface="+mn-ea"/>
+                <a:cs typeface="+mn-cs"/>
+              </a:defRPr>
+            </a:lvl6pPr>
+            <a:lvl7pPr marL="2743200">
+              <a:defRPr>
+                <a:latin typeface="+mn-lt"/>
+                <a:ea typeface="+mn-ea"/>
+                <a:cs typeface="+mn-cs"/>
+              </a:defRPr>
+            </a:lvl7pPr>
+            <a:lvl8pPr marL="3200400">
+              <a:defRPr>
+                <a:latin typeface="+mn-lt"/>
+                <a:ea typeface="+mn-ea"/>
+                <a:cs typeface="+mn-cs"/>
+              </a:defRPr>
+            </a:lvl8pPr>
+            <a:lvl9pPr marL="3657600">
+              <a:defRPr>
+                <a:latin typeface="+mn-lt"/>
+                <a:ea typeface="+mn-ea"/>
+                <a:cs typeface="+mn-cs"/>
+              </a:defRPr>
+            </a:lvl9pPr>
+          </a:lstStyle>
+          <a:p>
+            <a:pPr algn="just"/>
+            <a:r>
+              <a:rPr lang="en-US" sz="1400" dirty="0">
+                <a:latin typeface="Arial" panose="020B0604020202020204" pitchFamily="34" charset="0"/>
+                <a:cs typeface="Arial" panose="020B0604020202020204" pitchFamily="34" charset="0"/>
+              </a:rPr>
+              <a:t>Se </a:t>
+            </a:r>
+            <a:r>
+              <a:rPr lang="en-US" sz="1400" dirty="0" err="1">
+                <a:latin typeface="Arial" panose="020B0604020202020204" pitchFamily="34" charset="0"/>
+                <a:cs typeface="Arial" panose="020B0604020202020204" pitchFamily="34" charset="0"/>
+              </a:rPr>
+              <a:t>puede</a:t>
+            </a:r>
+            <a:r>
+              <a:rPr lang="en-US" sz="1400" dirty="0">
+                <a:latin typeface="Arial" panose="020B0604020202020204" pitchFamily="34" charset="0"/>
+                <a:cs typeface="Arial" panose="020B0604020202020204" pitchFamily="34" charset="0"/>
+              </a:rPr>
+              <a:t> </a:t>
+            </a:r>
+            <a:r>
+              <a:rPr lang="en-US" sz="1400" dirty="0" err="1">
+                <a:latin typeface="Arial" panose="020B0604020202020204" pitchFamily="34" charset="0"/>
+                <a:cs typeface="Arial" panose="020B0604020202020204" pitchFamily="34" charset="0"/>
+              </a:rPr>
+              <a:t>observar</a:t>
+            </a:r>
+            <a:r>
+              <a:rPr lang="en-US" sz="1400" dirty="0">
+                <a:latin typeface="Arial" panose="020B0604020202020204" pitchFamily="34" charset="0"/>
+                <a:cs typeface="Arial" panose="020B0604020202020204" pitchFamily="34" charset="0"/>
+              </a:rPr>
+              <a:t> </a:t>
+            </a:r>
+            <a:r>
+              <a:rPr lang="en-US" sz="1400" dirty="0" err="1">
+                <a:latin typeface="Arial" panose="020B0604020202020204" pitchFamily="34" charset="0"/>
+                <a:cs typeface="Arial" panose="020B0604020202020204" pitchFamily="34" charset="0"/>
+              </a:rPr>
+              <a:t>en</a:t>
+            </a:r>
+            <a:r>
+              <a:rPr lang="en-US" sz="1400" dirty="0">
+                <a:latin typeface="Arial" panose="020B0604020202020204" pitchFamily="34" charset="0"/>
+                <a:cs typeface="Arial" panose="020B0604020202020204" pitchFamily="34" charset="0"/>
+              </a:rPr>
+              <a:t> </a:t>
+            </a:r>
+            <a:r>
+              <a:rPr lang="en-US" sz="1400" dirty="0" err="1">
+                <a:latin typeface="Arial" panose="020B0604020202020204" pitchFamily="34" charset="0"/>
+                <a:cs typeface="Arial" panose="020B0604020202020204" pitchFamily="34" charset="0"/>
+              </a:rPr>
+              <a:t>los</a:t>
+            </a:r>
+            <a:r>
+              <a:rPr lang="en-US" sz="1400" dirty="0">
+                <a:latin typeface="Arial" panose="020B0604020202020204" pitchFamily="34" charset="0"/>
+                <a:cs typeface="Arial" panose="020B0604020202020204" pitchFamily="34" charset="0"/>
+              </a:rPr>
+              <a:t> plots </a:t>
+            </a:r>
+            <a:r>
+              <a:rPr lang="en-US" sz="1400" dirty="0" err="1">
+                <a:latin typeface="Arial" panose="020B0604020202020204" pitchFamily="34" charset="0"/>
+                <a:cs typeface="Arial" panose="020B0604020202020204" pitchFamily="34" charset="0"/>
+              </a:rPr>
+              <a:t>que</a:t>
+            </a:r>
+            <a:r>
+              <a:rPr lang="en-US" sz="1400" dirty="0">
+                <a:latin typeface="Arial" panose="020B0604020202020204" pitchFamily="34" charset="0"/>
+                <a:cs typeface="Arial" panose="020B0604020202020204" pitchFamily="34" charset="0"/>
+              </a:rPr>
+              <a:t> </a:t>
+            </a:r>
+            <a:r>
+              <a:rPr lang="en-US" sz="1400" dirty="0" err="1">
+                <a:latin typeface="Arial" panose="020B0604020202020204" pitchFamily="34" charset="0"/>
+                <a:cs typeface="Arial" panose="020B0604020202020204" pitchFamily="34" charset="0"/>
+              </a:rPr>
+              <a:t>el</a:t>
+            </a:r>
+            <a:r>
+              <a:rPr lang="en-US" sz="1400" dirty="0">
+                <a:latin typeface="Arial" panose="020B0604020202020204" pitchFamily="34" charset="0"/>
+                <a:cs typeface="Arial" panose="020B0604020202020204" pitchFamily="34" charset="0"/>
+              </a:rPr>
+              <a:t> campo </a:t>
+            </a:r>
+            <a:r>
+              <a:rPr lang="en-US" sz="1400" dirty="0" err="1">
+                <a:latin typeface="Arial" panose="020B0604020202020204" pitchFamily="34" charset="0"/>
+                <a:cs typeface="Arial" panose="020B0604020202020204" pitchFamily="34" charset="0"/>
+              </a:rPr>
+              <a:t>en</a:t>
+            </a:r>
+            <a:r>
+              <a:rPr lang="en-US" sz="1400" dirty="0">
+                <a:latin typeface="Arial" panose="020B0604020202020204" pitchFamily="34" charset="0"/>
+                <a:cs typeface="Arial" panose="020B0604020202020204" pitchFamily="34" charset="0"/>
+              </a:rPr>
+              <a:t> </a:t>
+            </a:r>
+            <a:r>
+              <a:rPr lang="en-US" sz="1400" dirty="0" err="1">
+                <a:latin typeface="Arial" panose="020B0604020202020204" pitchFamily="34" charset="0"/>
+                <a:cs typeface="Arial" panose="020B0604020202020204" pitchFamily="34" charset="0"/>
+              </a:rPr>
+              <a:t>los</a:t>
+            </a:r>
+            <a:r>
+              <a:rPr lang="en-US" sz="1400" dirty="0">
+                <a:latin typeface="Arial" panose="020B0604020202020204" pitchFamily="34" charset="0"/>
+                <a:cs typeface="Arial" panose="020B0604020202020204" pitchFamily="34" charset="0"/>
+              </a:rPr>
+              <a:t> </a:t>
+            </a:r>
+            <a:r>
+              <a:rPr lang="en-US" sz="1400" dirty="0" err="1">
+                <a:latin typeface="Arial" panose="020B0604020202020204" pitchFamily="34" charset="0"/>
+                <a:cs typeface="Arial" panose="020B0604020202020204" pitchFamily="34" charset="0"/>
+              </a:rPr>
+              <a:t>modos</a:t>
+            </a:r>
+            <a:r>
+              <a:rPr lang="en-US" sz="1400" dirty="0">
+                <a:latin typeface="Arial" panose="020B0604020202020204" pitchFamily="34" charset="0"/>
+                <a:cs typeface="Arial" panose="020B0604020202020204" pitchFamily="34" charset="0"/>
+              </a:rPr>
+              <a:t> 0 (TE) y 1 (TM) </a:t>
+            </a:r>
+            <a:r>
+              <a:rPr lang="en-US" sz="1400" dirty="0" err="1">
+                <a:latin typeface="Arial" panose="020B0604020202020204" pitchFamily="34" charset="0"/>
+                <a:cs typeface="Arial" panose="020B0604020202020204" pitchFamily="34" charset="0"/>
+              </a:rPr>
+              <a:t>estan</a:t>
+            </a:r>
+            <a:r>
+              <a:rPr lang="en-US" sz="1400" dirty="0">
+                <a:latin typeface="Arial" panose="020B0604020202020204" pitchFamily="34" charset="0"/>
+                <a:cs typeface="Arial" panose="020B0604020202020204" pitchFamily="34" charset="0"/>
+              </a:rPr>
+              <a:t> </a:t>
+            </a:r>
+            <a:r>
+              <a:rPr lang="en-US" sz="1400" dirty="0" err="1">
+                <a:latin typeface="Arial" panose="020B0604020202020204" pitchFamily="34" charset="0"/>
+                <a:cs typeface="Arial" panose="020B0604020202020204" pitchFamily="34" charset="0"/>
+              </a:rPr>
+              <a:t>confinados</a:t>
+            </a:r>
+            <a:r>
+              <a:rPr lang="en-US" sz="1400" dirty="0">
+                <a:latin typeface="Arial" panose="020B0604020202020204" pitchFamily="34" charset="0"/>
+                <a:cs typeface="Arial" panose="020B0604020202020204" pitchFamily="34" charset="0"/>
+              </a:rPr>
+              <a:t> a </a:t>
+            </a:r>
+            <a:r>
+              <a:rPr lang="en-US" sz="1400" dirty="0" err="1">
+                <a:latin typeface="Arial" panose="020B0604020202020204" pitchFamily="34" charset="0"/>
+                <a:cs typeface="Arial" panose="020B0604020202020204" pitchFamily="34" charset="0"/>
+              </a:rPr>
+              <a:t>diferencia</a:t>
+            </a:r>
+            <a:r>
+              <a:rPr lang="en-US" sz="1400" dirty="0">
+                <a:latin typeface="Arial" panose="020B0604020202020204" pitchFamily="34" charset="0"/>
+                <a:cs typeface="Arial" panose="020B0604020202020204" pitchFamily="34" charset="0"/>
+              </a:rPr>
+              <a:t> de </a:t>
+            </a:r>
+            <a:r>
+              <a:rPr lang="en-US" sz="1400" dirty="0" err="1">
+                <a:latin typeface="Arial" panose="020B0604020202020204" pitchFamily="34" charset="0"/>
+                <a:cs typeface="Arial" panose="020B0604020202020204" pitchFamily="34" charset="0"/>
+              </a:rPr>
+              <a:t>los</a:t>
+            </a:r>
+            <a:r>
+              <a:rPr lang="en-US" sz="1400" dirty="0">
+                <a:latin typeface="Arial" panose="020B0604020202020204" pitchFamily="34" charset="0"/>
+                <a:cs typeface="Arial" panose="020B0604020202020204" pitchFamily="34" charset="0"/>
+              </a:rPr>
+              <a:t> </a:t>
+            </a:r>
+            <a:r>
+              <a:rPr lang="en-US" sz="1400" dirty="0" err="1">
+                <a:latin typeface="Arial" panose="020B0604020202020204" pitchFamily="34" charset="0"/>
+                <a:cs typeface="Arial" panose="020B0604020202020204" pitchFamily="34" charset="0"/>
+              </a:rPr>
+              <a:t>modos</a:t>
+            </a:r>
+            <a:r>
+              <a:rPr lang="en-US" sz="1400" dirty="0">
+                <a:latin typeface="Arial" panose="020B0604020202020204" pitchFamily="34" charset="0"/>
+                <a:cs typeface="Arial" panose="020B0604020202020204" pitchFamily="34" charset="0"/>
+              </a:rPr>
+              <a:t> 2 (TE) y 3 (TM) </a:t>
+            </a:r>
+            <a:r>
+              <a:rPr lang="en-US" sz="1400" dirty="0" err="1">
+                <a:latin typeface="Arial" panose="020B0604020202020204" pitchFamily="34" charset="0"/>
+                <a:cs typeface="Arial" panose="020B0604020202020204" pitchFamily="34" charset="0"/>
+              </a:rPr>
+              <a:t>que</a:t>
+            </a:r>
+            <a:r>
+              <a:rPr lang="en-US" sz="1400" dirty="0">
+                <a:latin typeface="Arial" panose="020B0604020202020204" pitchFamily="34" charset="0"/>
+                <a:cs typeface="Arial" panose="020B0604020202020204" pitchFamily="34" charset="0"/>
+              </a:rPr>
+              <a:t> no </a:t>
+            </a:r>
+            <a:r>
+              <a:rPr lang="en-US" sz="1400" dirty="0" err="1">
+                <a:latin typeface="Arial" panose="020B0604020202020204" pitchFamily="34" charset="0"/>
+                <a:cs typeface="Arial" panose="020B0604020202020204" pitchFamily="34" charset="0"/>
+              </a:rPr>
+              <a:t>estan</a:t>
+            </a:r>
+            <a:r>
+              <a:rPr lang="en-US" sz="1400" dirty="0">
+                <a:latin typeface="Arial" panose="020B0604020202020204" pitchFamily="34" charset="0"/>
+                <a:cs typeface="Arial" panose="020B0604020202020204" pitchFamily="34" charset="0"/>
+              </a:rPr>
+              <a:t> </a:t>
+            </a:r>
+            <a:r>
+              <a:rPr lang="en-US" sz="1400" dirty="0" err="1">
+                <a:latin typeface="Arial" panose="020B0604020202020204" pitchFamily="34" charset="0"/>
+                <a:cs typeface="Arial" panose="020B0604020202020204" pitchFamily="34" charset="0"/>
+              </a:rPr>
+              <a:t>confinados</a:t>
+            </a:r>
+            <a:r>
+              <a:rPr lang="en-US" sz="1400" dirty="0">
+                <a:latin typeface="Arial" panose="020B0604020202020204" pitchFamily="34" charset="0"/>
+                <a:cs typeface="Arial" panose="020B0604020202020204" pitchFamily="34" charset="0"/>
+              </a:rPr>
+              <a:t>.</a:t>
+            </a:r>
+          </a:p>
+          <a:p>
+            <a:pPr algn="just"/>
+            <a:endParaRPr lang="en-US" sz="1400" dirty="0">
+              <a:latin typeface="Arial" panose="020B0604020202020204" pitchFamily="34" charset="0"/>
+              <a:cs typeface="Arial" panose="020B0604020202020204" pitchFamily="34" charset="0"/>
+            </a:endParaRPr>
+          </a:p>
+          <a:p>
+            <a:pPr algn="just"/>
+            <a:endParaRPr lang="en-US" sz="1400" dirty="0">
+              <a:latin typeface="Arial" panose="020B0604020202020204" pitchFamily="34" charset="0"/>
+              <a:cs typeface="Arial" panose="020B0604020202020204" pitchFamily="34" charset="0"/>
+            </a:endParaRPr>
+          </a:p>
+          <a:p>
+            <a:pPr algn="just"/>
+            <a:endParaRPr lang="en-US" sz="1400" dirty="0">
+              <a:latin typeface="Arial" panose="020B0604020202020204" pitchFamily="34" charset="0"/>
+              <a:cs typeface="Arial" panose="020B0604020202020204" pitchFamily="34" charset="0"/>
+            </a:endParaRPr>
+          </a:p>
+          <a:p>
+            <a:endParaRPr lang="es-ES" sz="1400" kern="0" dirty="0">
+              <a:solidFill>
+                <a:sysClr val="windowText" lastClr="000000"/>
+              </a:solidFill>
+            </a:endParaRPr>
+          </a:p>
+        </p:txBody>
+      </p:sp>
+      <p:pic>
+        <p:nvPicPr>
+          <p:cNvPr id="10" name="Imagen 9" descr="Histograma&#10;&#10;El contenido generado por IA puede ser incorrecto.">
+            <a:extLst>
+              <a:ext uri="{FF2B5EF4-FFF2-40B4-BE49-F238E27FC236}">
+                <a16:creationId xmlns:a16="http://schemas.microsoft.com/office/drawing/2014/main" id="{B48F81A6-BE1C-E6C0-6D02-DBCAA7D1FF29}"/>
+              </a:ext>
+            </a:extLst>
+          </p:cNvPr>
+          <p:cNvPicPr>
+            <a:picLocks noChangeAspect="1"/>
+          </p:cNvPicPr>
+          <p:nvPr/>
+        </p:nvPicPr>
+        <p:blipFill>
+          <a:blip r:embed="rId3"/>
+          <a:stretch>
+            <a:fillRect/>
+          </a:stretch>
+        </p:blipFill>
+        <p:spPr>
+          <a:xfrm>
+            <a:off x="5790452" y="1147735"/>
+            <a:ext cx="2210548" cy="1292662"/>
+          </a:xfrm>
+          <a:prstGeom prst="rect">
+            <a:avLst/>
+          </a:prstGeom>
+        </p:spPr>
+      </p:pic>
+      <p:pic>
+        <p:nvPicPr>
+          <p:cNvPr id="12" name="Imagen 11" descr="Gráfico&#10;&#10;El contenido generado por IA puede ser incorrecto.">
+            <a:extLst>
+              <a:ext uri="{FF2B5EF4-FFF2-40B4-BE49-F238E27FC236}">
+                <a16:creationId xmlns:a16="http://schemas.microsoft.com/office/drawing/2014/main" id="{60E818AF-B43A-E6B8-9A93-97D8F70C9F19}"/>
+              </a:ext>
+            </a:extLst>
+          </p:cNvPr>
+          <p:cNvPicPr>
+            <a:picLocks noChangeAspect="1"/>
+          </p:cNvPicPr>
+          <p:nvPr/>
+        </p:nvPicPr>
+        <p:blipFill>
+          <a:blip r:embed="rId4"/>
+          <a:stretch>
+            <a:fillRect/>
+          </a:stretch>
+        </p:blipFill>
+        <p:spPr>
+          <a:xfrm>
+            <a:off x="8001000" y="1043326"/>
+            <a:ext cx="2412289" cy="1292662"/>
+          </a:xfrm>
+          <a:prstGeom prst="rect">
+            <a:avLst/>
+          </a:prstGeom>
+        </p:spPr>
+      </p:pic>
+      <p:pic>
+        <p:nvPicPr>
+          <p:cNvPr id="14" name="Imagen 13" descr="Imagen que contiene Gráfico&#10;&#10;El contenido generado por IA puede ser incorrecto.">
+            <a:extLst>
+              <a:ext uri="{FF2B5EF4-FFF2-40B4-BE49-F238E27FC236}">
+                <a16:creationId xmlns:a16="http://schemas.microsoft.com/office/drawing/2014/main" id="{E9C2C45D-E055-687E-57E6-23AC6E64ADB1}"/>
+              </a:ext>
+            </a:extLst>
+          </p:cNvPr>
+          <p:cNvPicPr>
+            <a:picLocks noChangeAspect="1"/>
+          </p:cNvPicPr>
+          <p:nvPr/>
+        </p:nvPicPr>
+        <p:blipFill>
+          <a:blip r:embed="rId5"/>
+          <a:stretch>
+            <a:fillRect/>
+          </a:stretch>
+        </p:blipFill>
+        <p:spPr>
+          <a:xfrm>
+            <a:off x="5962855" y="2474155"/>
+            <a:ext cx="2073912" cy="1116503"/>
+          </a:xfrm>
+          <a:prstGeom prst="rect">
+            <a:avLst/>
+          </a:prstGeom>
+        </p:spPr>
+      </p:pic>
+      <p:pic>
+        <p:nvPicPr>
+          <p:cNvPr id="16" name="Imagen 15" descr="Imagen que contiene Gráfico&#10;&#10;El contenido generado por IA puede ser incorrecto.">
+            <a:extLst>
+              <a:ext uri="{FF2B5EF4-FFF2-40B4-BE49-F238E27FC236}">
+                <a16:creationId xmlns:a16="http://schemas.microsoft.com/office/drawing/2014/main" id="{7F999343-8AEB-DF27-2556-89F7BEEFAD30}"/>
+              </a:ext>
+            </a:extLst>
+          </p:cNvPr>
+          <p:cNvPicPr>
+            <a:picLocks noChangeAspect="1"/>
+          </p:cNvPicPr>
+          <p:nvPr/>
+        </p:nvPicPr>
+        <p:blipFill>
+          <a:blip r:embed="rId6"/>
+          <a:stretch>
+            <a:fillRect/>
+          </a:stretch>
+        </p:blipFill>
+        <p:spPr>
+          <a:xfrm>
+            <a:off x="8214369" y="2474155"/>
+            <a:ext cx="2234687" cy="1126655"/>
+          </a:xfrm>
+          <a:prstGeom prst="rect">
+            <a:avLst/>
+          </a:prstGeom>
+        </p:spPr>
+      </p:pic>
+    </p:spTree>
+    <p:extLst>
+      <p:ext uri="{BB962C8B-B14F-4D97-AF65-F5344CB8AC3E}">
+        <p14:creationId xmlns:p14="http://schemas.microsoft.com/office/powerpoint/2010/main" val="219364629"/>
+      </p:ext>
+    </p:extLst>
+  </p:cSld>
+  <p:clrMapOvr>
+    <a:masterClrMapping/>
+  </p:clrMapOvr>
+</p:sld>
+</file>
+
+<file path=ppt/slides/slide5.xml><?xml version="1.0" encoding="utf-8"?>
 <p:sld xmlns:a="http://schemas.openxmlformats.org/drawingml/2006/main" xmlns:r="http://schemas.openxmlformats.org/officeDocument/2006/relationships" xmlns:p="http://schemas.openxmlformats.org/presentationml/2006/main">
   <p:cSld>
     <p:spTree>
@@ -6134,7 +7239,7 @@
           <a:p>
             <a:fld id="{B6F15528-21DE-4FAA-801E-634DDDAF4B2B}" type="slidenum">
               <a:rPr lang="es-ES" smtClean="0"/>
-              <a:t>4</a:t>
+              <a:t>5</a:t>
             </a:fld>
             <a:endParaRPr lang="es-ES"/>
           </a:p>
@@ -6188,7 +7293,7 @@
         <p:spPr>
           <a:xfrm>
             <a:off x="609441" y="4860334"/>
-            <a:ext cx="11199971" cy="1384995"/>
+            <a:ext cx="11199971" cy="830997"/>
           </a:xfrm>
           <a:prstGeom prst="rect">
             <a:avLst/>
@@ -6303,13 +7408,111 @@
                 <a:latin typeface="Arial" panose="020B0604020202020204" pitchFamily="34" charset="0"/>
                 <a:cs typeface="Arial" panose="020B0604020202020204" pitchFamily="34" charset="0"/>
               </a:rPr>
-              <a:t>, </a:t>
+              <a:t> </a:t>
             </a:r>
             <a:r>
               <a:rPr lang="en-US" sz="1200" dirty="0" err="1">
                 <a:latin typeface="Arial" panose="020B0604020202020204" pitchFamily="34" charset="0"/>
                 <a:cs typeface="Arial" panose="020B0604020202020204" pitchFamily="34" charset="0"/>
               </a:rPr>
+              <a:t>ya</a:t>
+            </a:r>
+            <a:r>
+              <a:rPr lang="en-US" sz="1200" dirty="0">
+                <a:latin typeface="Arial" panose="020B0604020202020204" pitchFamily="34" charset="0"/>
+                <a:cs typeface="Arial" panose="020B0604020202020204" pitchFamily="34" charset="0"/>
+              </a:rPr>
+              <a:t> </a:t>
+            </a:r>
+            <a:r>
+              <a:rPr lang="en-US" sz="1200" dirty="0" err="1">
+                <a:latin typeface="Arial" panose="020B0604020202020204" pitchFamily="34" charset="0"/>
+                <a:cs typeface="Arial" panose="020B0604020202020204" pitchFamily="34" charset="0"/>
+              </a:rPr>
+              <a:t>que</a:t>
+            </a:r>
+            <a:r>
+              <a:rPr lang="en-US" sz="1200" dirty="0">
+                <a:latin typeface="Arial" panose="020B0604020202020204" pitchFamily="34" charset="0"/>
+                <a:cs typeface="Arial" panose="020B0604020202020204" pitchFamily="34" charset="0"/>
+              </a:rPr>
+              <a:t> </a:t>
+            </a:r>
+            <a:r>
+              <a:rPr lang="en-US" sz="1200" dirty="0" err="1">
+                <a:latin typeface="Arial" panose="020B0604020202020204" pitchFamily="34" charset="0"/>
+                <a:cs typeface="Arial" panose="020B0604020202020204" pitchFamily="34" charset="0"/>
+              </a:rPr>
+              <a:t>su</a:t>
+            </a:r>
+            <a:r>
+              <a:rPr lang="en-US" sz="1200" dirty="0">
+                <a:latin typeface="Arial" panose="020B0604020202020204" pitchFamily="34" charset="0"/>
+                <a:cs typeface="Arial" panose="020B0604020202020204" pitchFamily="34" charset="0"/>
+              </a:rPr>
+              <a:t> </a:t>
+            </a:r>
+            <a:r>
+              <a:rPr lang="en-US" sz="1200" dirty="0" err="1">
+                <a:latin typeface="Arial" panose="020B0604020202020204" pitchFamily="34" charset="0"/>
+                <a:cs typeface="Arial" panose="020B0604020202020204" pitchFamily="34" charset="0"/>
+              </a:rPr>
+              <a:t>indice</a:t>
+            </a:r>
+            <a:r>
+              <a:rPr lang="en-US" sz="1200" dirty="0">
+                <a:latin typeface="Arial" panose="020B0604020202020204" pitchFamily="34" charset="0"/>
+                <a:cs typeface="Arial" panose="020B0604020202020204" pitchFamily="34" charset="0"/>
+              </a:rPr>
+              <a:t> de </a:t>
+            </a:r>
+            <a:r>
+              <a:rPr lang="en-US" sz="1200" dirty="0" err="1">
+                <a:latin typeface="Arial" panose="020B0604020202020204" pitchFamily="34" charset="0"/>
+                <a:cs typeface="Arial" panose="020B0604020202020204" pitchFamily="34" charset="0"/>
+              </a:rPr>
+              <a:t>refracción</a:t>
+            </a:r>
+            <a:r>
+              <a:rPr lang="en-US" sz="1200" dirty="0">
+                <a:latin typeface="Arial" panose="020B0604020202020204" pitchFamily="34" charset="0"/>
+                <a:cs typeface="Arial" panose="020B0604020202020204" pitchFamily="34" charset="0"/>
+              </a:rPr>
+              <a:t> </a:t>
+            </a:r>
+            <a:r>
+              <a:rPr lang="en-US" sz="1200" dirty="0" err="1">
+                <a:latin typeface="Arial" panose="020B0604020202020204" pitchFamily="34" charset="0"/>
+                <a:cs typeface="Arial" panose="020B0604020202020204" pitchFamily="34" charset="0"/>
+              </a:rPr>
+              <a:t>efectivo</a:t>
+            </a:r>
+            <a:r>
+              <a:rPr lang="en-US" sz="1200" dirty="0">
+                <a:latin typeface="Arial" panose="020B0604020202020204" pitchFamily="34" charset="0"/>
+                <a:cs typeface="Arial" panose="020B0604020202020204" pitchFamily="34" charset="0"/>
+              </a:rPr>
+              <a:t> es superior al </a:t>
+            </a:r>
+            <a:r>
+              <a:rPr lang="en-US" sz="1200" dirty="0" err="1">
+                <a:latin typeface="Arial" panose="020B0604020202020204" pitchFamily="34" charset="0"/>
+                <a:cs typeface="Arial" panose="020B0604020202020204" pitchFamily="34" charset="0"/>
+              </a:rPr>
+              <a:t>índice</a:t>
+            </a:r>
+            <a:r>
+              <a:rPr lang="en-US" sz="1200" dirty="0">
+                <a:latin typeface="Arial" panose="020B0604020202020204" pitchFamily="34" charset="0"/>
+                <a:cs typeface="Arial" panose="020B0604020202020204" pitchFamily="34" charset="0"/>
+              </a:rPr>
+              <a:t> del SiO2 , </a:t>
+            </a:r>
+            <a:r>
+              <a:rPr lang="en-US" sz="1200" dirty="0" err="1">
+                <a:latin typeface="Arial" panose="020B0604020202020204" pitchFamily="34" charset="0"/>
+                <a:cs typeface="Arial" panose="020B0604020202020204" pitchFamily="34" charset="0"/>
+              </a:rPr>
               <a:t>en</a:t>
             </a:r>
             <a:r>
@@ -6487,159 +7690,6 @@
               </a:rPr>
               <a:t> del cladding.</a:t>
             </a:r>
-          </a:p>
-          <a:p>
-            <a:pPr algn="just"/>
-            <a:r>
-              <a:rPr lang="en-US" sz="1200" dirty="0">
-                <a:latin typeface="Arial" panose="020B0604020202020204" pitchFamily="34" charset="0"/>
-                <a:cs typeface="Arial" panose="020B0604020202020204" pitchFamily="34" charset="0"/>
-              </a:rPr>
-              <a:t>Con la </a:t>
-            </a:r>
-            <a:r>
-              <a:rPr lang="en-US" sz="1200" dirty="0" err="1">
-                <a:latin typeface="Arial" panose="020B0604020202020204" pitchFamily="34" charset="0"/>
-                <a:cs typeface="Arial" panose="020B0604020202020204" pitchFamily="34" charset="0"/>
-              </a:rPr>
-              <a:t>guia</a:t>
-            </a:r>
-            <a:r>
-              <a:rPr lang="en-US" sz="1200" dirty="0">
-                <a:latin typeface="Arial" panose="020B0604020202020204" pitchFamily="34" charset="0"/>
-                <a:cs typeface="Arial" panose="020B0604020202020204" pitchFamily="34" charset="0"/>
-              </a:rPr>
-              <a:t> shallow </a:t>
-            </a:r>
-            <a:r>
-              <a:rPr lang="en-US" sz="1200" dirty="0" err="1">
-                <a:latin typeface="Arial" panose="020B0604020202020204" pitchFamily="34" charset="0"/>
-                <a:cs typeface="Arial" panose="020B0604020202020204" pitchFamily="34" charset="0"/>
-              </a:rPr>
-              <a:t>los</a:t>
-            </a:r>
-            <a:r>
-              <a:rPr lang="en-US" sz="1200" dirty="0">
-                <a:latin typeface="Arial" panose="020B0604020202020204" pitchFamily="34" charset="0"/>
-                <a:cs typeface="Arial" panose="020B0604020202020204" pitchFamily="34" charset="0"/>
-              </a:rPr>
-              <a:t> </a:t>
-            </a:r>
-            <a:r>
-              <a:rPr lang="en-US" sz="1200" dirty="0" err="1">
-                <a:latin typeface="Arial" panose="020B0604020202020204" pitchFamily="34" charset="0"/>
-                <a:cs typeface="Arial" panose="020B0604020202020204" pitchFamily="34" charset="0"/>
-              </a:rPr>
-              <a:t>modos</a:t>
-            </a:r>
-            <a:r>
-              <a:rPr lang="en-US" sz="1200" dirty="0">
-                <a:latin typeface="Arial" panose="020B0604020202020204" pitchFamily="34" charset="0"/>
-                <a:cs typeface="Arial" panose="020B0604020202020204" pitchFamily="34" charset="0"/>
-              </a:rPr>
-              <a:t> 0,y 3 son TE y </a:t>
-            </a:r>
-            <a:r>
-              <a:rPr lang="en-US" sz="1200" dirty="0" err="1">
-                <a:latin typeface="Arial" panose="020B0604020202020204" pitchFamily="34" charset="0"/>
-                <a:cs typeface="Arial" panose="020B0604020202020204" pitchFamily="34" charset="0"/>
-              </a:rPr>
-              <a:t>el</a:t>
-            </a:r>
-            <a:r>
-              <a:rPr lang="en-US" sz="1200" dirty="0">
-                <a:latin typeface="Arial" panose="020B0604020202020204" pitchFamily="34" charset="0"/>
-                <a:cs typeface="Arial" panose="020B0604020202020204" pitchFamily="34" charset="0"/>
-              </a:rPr>
-              <a:t> modo 2 es TM. El modo 1 es </a:t>
-            </a:r>
-            <a:r>
-              <a:rPr lang="en-US" sz="1200" dirty="0" err="1">
-                <a:latin typeface="Arial" panose="020B0604020202020204" pitchFamily="34" charset="0"/>
-                <a:cs typeface="Arial" panose="020B0604020202020204" pitchFamily="34" charset="0"/>
-              </a:rPr>
-              <a:t>hibrido</a:t>
-            </a:r>
-            <a:r>
-              <a:rPr lang="en-US" sz="1200" dirty="0">
-                <a:latin typeface="Arial" panose="020B0604020202020204" pitchFamily="34" charset="0"/>
-                <a:cs typeface="Arial" panose="020B0604020202020204" pitchFamily="34" charset="0"/>
-              </a:rPr>
-              <a:t>.</a:t>
-            </a:r>
-          </a:p>
-          <a:p>
-            <a:pPr algn="just"/>
-            <a:r>
-              <a:rPr lang="en-US" sz="1200" dirty="0">
-                <a:latin typeface="Arial" panose="020B0604020202020204" pitchFamily="34" charset="0"/>
-                <a:cs typeface="Arial" panose="020B0604020202020204" pitchFamily="34" charset="0"/>
-              </a:rPr>
-              <a:t>Con la </a:t>
-            </a:r>
-            <a:r>
-              <a:rPr lang="en-US" sz="1200" dirty="0" err="1">
-                <a:latin typeface="Arial" panose="020B0604020202020204" pitchFamily="34" charset="0"/>
-                <a:cs typeface="Arial" panose="020B0604020202020204" pitchFamily="34" charset="0"/>
-              </a:rPr>
-              <a:t>guia</a:t>
-            </a:r>
-            <a:r>
-              <a:rPr lang="en-US" sz="1200" dirty="0">
-                <a:latin typeface="Arial" panose="020B0604020202020204" pitchFamily="34" charset="0"/>
-                <a:cs typeface="Arial" panose="020B0604020202020204" pitchFamily="34" charset="0"/>
-              </a:rPr>
-              <a:t> deep </a:t>
-            </a:r>
-            <a:r>
-              <a:rPr lang="en-US" sz="1200" dirty="0" err="1">
-                <a:latin typeface="Arial" panose="020B0604020202020204" pitchFamily="34" charset="0"/>
-                <a:cs typeface="Arial" panose="020B0604020202020204" pitchFamily="34" charset="0"/>
-              </a:rPr>
-              <a:t>los</a:t>
-            </a:r>
-            <a:r>
-              <a:rPr lang="en-US" sz="1200" dirty="0">
-                <a:latin typeface="Arial" panose="020B0604020202020204" pitchFamily="34" charset="0"/>
-                <a:cs typeface="Arial" panose="020B0604020202020204" pitchFamily="34" charset="0"/>
-              </a:rPr>
-              <a:t> </a:t>
-            </a:r>
-            <a:r>
-              <a:rPr lang="en-US" sz="1200" dirty="0" err="1">
-                <a:latin typeface="Arial" panose="020B0604020202020204" pitchFamily="34" charset="0"/>
-                <a:cs typeface="Arial" panose="020B0604020202020204" pitchFamily="34" charset="0"/>
-              </a:rPr>
-              <a:t>modos</a:t>
-            </a:r>
-            <a:r>
-              <a:rPr lang="en-US" sz="1200" dirty="0">
-                <a:latin typeface="Arial" panose="020B0604020202020204" pitchFamily="34" charset="0"/>
-                <a:cs typeface="Arial" panose="020B0604020202020204" pitchFamily="34" charset="0"/>
-              </a:rPr>
-              <a:t> 0 y 2 son TE y </a:t>
-            </a:r>
-            <a:r>
-              <a:rPr lang="en-US" sz="1200" dirty="0" err="1">
-                <a:latin typeface="Arial" panose="020B0604020202020204" pitchFamily="34" charset="0"/>
-                <a:cs typeface="Arial" panose="020B0604020202020204" pitchFamily="34" charset="0"/>
-              </a:rPr>
-              <a:t>el</a:t>
-            </a:r>
-            <a:r>
-              <a:rPr lang="en-US" sz="1200" dirty="0">
-                <a:latin typeface="Arial" panose="020B0604020202020204" pitchFamily="34" charset="0"/>
-                <a:cs typeface="Arial" panose="020B0604020202020204" pitchFamily="34" charset="0"/>
-              </a:rPr>
-              <a:t> 1 y 3 son TM.</a:t>
-            </a:r>
-          </a:p>
-          <a:p>
-            <a:pPr algn="just"/>
-            <a:endParaRPr lang="en-US" sz="1200" dirty="0">
-              <a:latin typeface="Arial" panose="020B0604020202020204" pitchFamily="34" charset="0"/>
-              <a:cs typeface="Arial" panose="020B0604020202020204" pitchFamily="34" charset="0"/>
-            </a:endParaRPr>
           </a:p>
         </p:txBody>
       </p:sp>
@@ -6962,7 +8012,7 @@
 </p:sld>
 </file>
 
-<file path=ppt/slides/slide5.xml><?xml version="1.0" encoding="utf-8"?>
+<file path=ppt/slides/slide6.xml><?xml version="1.0" encoding="utf-8"?>
 <p:sld xmlns:a="http://schemas.openxmlformats.org/drawingml/2006/main" xmlns:r="http://schemas.openxmlformats.org/officeDocument/2006/relationships" xmlns:p="http://schemas.openxmlformats.org/presentationml/2006/main">
   <p:cSld>
     <p:spTree>
@@ -6981,6 +8031,1283 @@
       </p:grpSpPr>
       <p:sp>
         <p:nvSpPr>
+          <p:cNvPr id="2" name="Título 1">
+            <a:extLst>
+              <a:ext uri="{FF2B5EF4-FFF2-40B4-BE49-F238E27FC236}">
+                <a16:creationId xmlns:a16="http://schemas.microsoft.com/office/drawing/2014/main" id="{74E64652-1DB7-E694-D36B-985DB6D75567}"/>
+              </a:ext>
+            </a:extLst>
+          </p:cNvPr>
+          <p:cNvSpPr>
+            <a:spLocks noGrp="1"/>
+          </p:cNvSpPr>
+          <p:nvPr>
+            <p:ph type="title"/>
+          </p:nvPr>
+        </p:nvSpPr>
+        <p:spPr/>
+        <p:txBody>
+          <a:bodyPr/>
+          <a:lstStyle/>
+          <a:p>
+            <a:r>
+              <a:rPr lang="es-ES" dirty="0"/>
+              <a:t>Comentarios</a:t>
+            </a:r>
+          </a:p>
+        </p:txBody>
+      </p:sp>
+      <p:sp>
+        <p:nvSpPr>
+          <p:cNvPr id="3" name="Marcador de texto 2">
+            <a:extLst>
+              <a:ext uri="{FF2B5EF4-FFF2-40B4-BE49-F238E27FC236}">
+                <a16:creationId xmlns:a16="http://schemas.microsoft.com/office/drawing/2014/main" id="{CD70538A-68E4-F5CA-1BBB-7CD552AAD551}"/>
+              </a:ext>
+            </a:extLst>
+          </p:cNvPr>
+          <p:cNvSpPr>
+            <a:spLocks noGrp="1"/>
+          </p:cNvSpPr>
+          <p:nvPr>
+            <p:ph type="body" idx="1"/>
+          </p:nvPr>
+        </p:nvSpPr>
+        <p:spPr>
+          <a:xfrm>
+            <a:off x="590550" y="685800"/>
+            <a:ext cx="5200650" cy="430887"/>
+          </a:xfrm>
+        </p:spPr>
+        <p:txBody>
+          <a:bodyPr/>
+          <a:lstStyle/>
+          <a:p>
+            <a:pPr algn="just"/>
+            <a:r>
+              <a:rPr lang="en-US" sz="1400" dirty="0">
+                <a:latin typeface="Arial" panose="020B0604020202020204" pitchFamily="34" charset="0"/>
+                <a:cs typeface="Arial" panose="020B0604020202020204" pitchFamily="34" charset="0"/>
+              </a:rPr>
+              <a:t>Con la </a:t>
+            </a:r>
+            <a:r>
+              <a:rPr lang="en-US" sz="1400" dirty="0" err="1">
+                <a:latin typeface="Arial" panose="020B0604020202020204" pitchFamily="34" charset="0"/>
+                <a:cs typeface="Arial" panose="020B0604020202020204" pitchFamily="34" charset="0"/>
+              </a:rPr>
+              <a:t>guia</a:t>
+            </a:r>
+            <a:r>
+              <a:rPr lang="en-US" sz="1400" dirty="0">
+                <a:latin typeface="Arial" panose="020B0604020202020204" pitchFamily="34" charset="0"/>
+                <a:cs typeface="Arial" panose="020B0604020202020204" pitchFamily="34" charset="0"/>
+              </a:rPr>
+              <a:t> shallow </a:t>
+            </a:r>
+            <a:r>
+              <a:rPr lang="en-US" sz="1400" dirty="0" err="1">
+                <a:latin typeface="Arial" panose="020B0604020202020204" pitchFamily="34" charset="0"/>
+                <a:cs typeface="Arial" panose="020B0604020202020204" pitchFamily="34" charset="0"/>
+              </a:rPr>
+              <a:t>los</a:t>
+            </a:r>
+            <a:r>
+              <a:rPr lang="en-US" sz="1400" dirty="0">
+                <a:latin typeface="Arial" panose="020B0604020202020204" pitchFamily="34" charset="0"/>
+                <a:cs typeface="Arial" panose="020B0604020202020204" pitchFamily="34" charset="0"/>
+              </a:rPr>
+              <a:t> </a:t>
+            </a:r>
+            <a:r>
+              <a:rPr lang="en-US" sz="1400" dirty="0" err="1">
+                <a:latin typeface="Arial" panose="020B0604020202020204" pitchFamily="34" charset="0"/>
+                <a:cs typeface="Arial" panose="020B0604020202020204" pitchFamily="34" charset="0"/>
+              </a:rPr>
+              <a:t>modos</a:t>
+            </a:r>
+            <a:r>
+              <a:rPr lang="en-US" sz="1400" dirty="0">
+                <a:latin typeface="Arial" panose="020B0604020202020204" pitchFamily="34" charset="0"/>
+                <a:cs typeface="Arial" panose="020B0604020202020204" pitchFamily="34" charset="0"/>
+              </a:rPr>
+              <a:t> 0,y 3 son TE y </a:t>
+            </a:r>
+            <a:r>
+              <a:rPr lang="en-US" sz="1400" dirty="0" err="1">
+                <a:latin typeface="Arial" panose="020B0604020202020204" pitchFamily="34" charset="0"/>
+                <a:cs typeface="Arial" panose="020B0604020202020204" pitchFamily="34" charset="0"/>
+              </a:rPr>
+              <a:t>los</a:t>
+            </a:r>
+            <a:r>
+              <a:rPr lang="en-US" sz="1400" dirty="0">
+                <a:latin typeface="Arial" panose="020B0604020202020204" pitchFamily="34" charset="0"/>
+                <a:cs typeface="Arial" panose="020B0604020202020204" pitchFamily="34" charset="0"/>
+              </a:rPr>
+              <a:t> </a:t>
+            </a:r>
+            <a:r>
+              <a:rPr lang="en-US" sz="1400" dirty="0" err="1">
+                <a:latin typeface="Arial" panose="020B0604020202020204" pitchFamily="34" charset="0"/>
+                <a:cs typeface="Arial" panose="020B0604020202020204" pitchFamily="34" charset="0"/>
+              </a:rPr>
+              <a:t>modos</a:t>
+            </a:r>
+            <a:r>
+              <a:rPr lang="en-US" sz="1400" dirty="0">
+                <a:latin typeface="Arial" panose="020B0604020202020204" pitchFamily="34" charset="0"/>
+                <a:cs typeface="Arial" panose="020B0604020202020204" pitchFamily="34" charset="0"/>
+              </a:rPr>
+              <a:t> 1 y 2 son </a:t>
+            </a:r>
+            <a:r>
+              <a:rPr lang="en-US" sz="1400" dirty="0" err="1">
+                <a:latin typeface="Arial" panose="020B0604020202020204" pitchFamily="34" charset="0"/>
+                <a:cs typeface="Arial" panose="020B0604020202020204" pitchFamily="34" charset="0"/>
+              </a:rPr>
+              <a:t>hibridos</a:t>
+            </a:r>
+            <a:r>
+              <a:rPr lang="en-US" sz="1400" dirty="0">
+                <a:latin typeface="Arial" panose="020B0604020202020204" pitchFamily="34" charset="0"/>
+                <a:cs typeface="Arial" panose="020B0604020202020204" pitchFamily="34" charset="0"/>
+              </a:rPr>
+              <a:t>, </a:t>
+            </a:r>
+            <a:r>
+              <a:rPr lang="en-US" sz="1400" dirty="0" err="1">
+                <a:latin typeface="Arial" panose="020B0604020202020204" pitchFamily="34" charset="0"/>
+                <a:cs typeface="Arial" panose="020B0604020202020204" pitchFamily="34" charset="0"/>
+              </a:rPr>
+              <a:t>mayoritariamente</a:t>
+            </a:r>
+            <a:r>
+              <a:rPr lang="en-US" sz="1400" dirty="0">
+                <a:latin typeface="Arial" panose="020B0604020202020204" pitchFamily="34" charset="0"/>
+                <a:cs typeface="Arial" panose="020B0604020202020204" pitchFamily="34" charset="0"/>
+              </a:rPr>
+              <a:t> TE.</a:t>
+            </a:r>
+          </a:p>
+          <a:p>
+            <a:endParaRPr lang="es-ES" sz="1400" dirty="0"/>
+          </a:p>
+        </p:txBody>
+      </p:sp>
+      <p:sp>
+        <p:nvSpPr>
+          <p:cNvPr id="4" name="Marcador de pie de página 3">
+            <a:extLst>
+              <a:ext uri="{FF2B5EF4-FFF2-40B4-BE49-F238E27FC236}">
+                <a16:creationId xmlns:a16="http://schemas.microsoft.com/office/drawing/2014/main" id="{69A70AEF-A0E3-E117-BB88-746F97AD7C23}"/>
+              </a:ext>
+            </a:extLst>
+          </p:cNvPr>
+          <p:cNvSpPr>
+            <a:spLocks noGrp="1"/>
+          </p:cNvSpPr>
+          <p:nvPr>
+            <p:ph type="ftr" sz="quarter" idx="5"/>
+          </p:nvPr>
+        </p:nvSpPr>
+        <p:spPr/>
+        <p:txBody>
+          <a:bodyPr/>
+          <a:lstStyle/>
+          <a:p>
+            <a:pPr marL="12700">
+              <a:spcBef>
+                <a:spcPts val="15"/>
+              </a:spcBef>
+            </a:pPr>
+            <a:r>
+              <a:rPr lang="es-ES" spc="-5"/>
+              <a:t>LAB 0.1. MODESOLVER</a:t>
+            </a:r>
+            <a:endParaRPr lang="es-ES" spc="-5" dirty="0"/>
+          </a:p>
+        </p:txBody>
+      </p:sp>
+      <p:sp>
+        <p:nvSpPr>
+          <p:cNvPr id="5" name="Marcador de número de diapositiva 4">
+            <a:extLst>
+              <a:ext uri="{FF2B5EF4-FFF2-40B4-BE49-F238E27FC236}">
+                <a16:creationId xmlns:a16="http://schemas.microsoft.com/office/drawing/2014/main" id="{B196C78E-166D-AE50-D427-CD26140F5941}"/>
+              </a:ext>
+            </a:extLst>
+          </p:cNvPr>
+          <p:cNvSpPr>
+            <a:spLocks noGrp="1"/>
+          </p:cNvSpPr>
+          <p:nvPr>
+            <p:ph type="sldNum" sz="quarter" idx="7"/>
+          </p:nvPr>
+        </p:nvSpPr>
+        <p:spPr/>
+        <p:txBody>
+          <a:bodyPr/>
+          <a:lstStyle/>
+          <a:p>
+            <a:fld id="{B6F15528-21DE-4FAA-801E-634DDDAF4B2B}" type="slidenum">
+              <a:rPr lang="es-ES" smtClean="0"/>
+              <a:t>6</a:t>
+            </a:fld>
+            <a:endParaRPr lang="es-ES"/>
+          </a:p>
+        </p:txBody>
+      </p:sp>
+      <p:pic>
+        <p:nvPicPr>
+          <p:cNvPr id="7" name="Imagen 6" descr="Texto&#10;&#10;El contenido generado por IA puede ser incorrecto.">
+            <a:extLst>
+              <a:ext uri="{FF2B5EF4-FFF2-40B4-BE49-F238E27FC236}">
+                <a16:creationId xmlns:a16="http://schemas.microsoft.com/office/drawing/2014/main" id="{D5E8ED96-2A1A-07AC-B725-88D2612B8CB6}"/>
+              </a:ext>
+            </a:extLst>
+          </p:cNvPr>
+          <p:cNvPicPr>
+            <a:picLocks noChangeAspect="1"/>
+          </p:cNvPicPr>
+          <p:nvPr/>
+        </p:nvPicPr>
+        <p:blipFill>
+          <a:blip r:embed="rId2"/>
+          <a:stretch>
+            <a:fillRect/>
+          </a:stretch>
+        </p:blipFill>
+        <p:spPr>
+          <a:xfrm>
+            <a:off x="590550" y="1224396"/>
+            <a:ext cx="5104614" cy="2562476"/>
+          </a:xfrm>
+          <a:prstGeom prst="rect">
+            <a:avLst/>
+          </a:prstGeom>
+        </p:spPr>
+      </p:pic>
+      <p:sp>
+        <p:nvSpPr>
+          <p:cNvPr id="8" name="Marcador de texto 2">
+            <a:extLst>
+              <a:ext uri="{FF2B5EF4-FFF2-40B4-BE49-F238E27FC236}">
+                <a16:creationId xmlns:a16="http://schemas.microsoft.com/office/drawing/2014/main" id="{15A913E1-D1BA-3C75-C94A-64EE39100AAA}"/>
+              </a:ext>
+            </a:extLst>
+          </p:cNvPr>
+          <p:cNvSpPr txBox="1">
+            <a:spLocks/>
+          </p:cNvSpPr>
+          <p:nvPr/>
+        </p:nvSpPr>
+        <p:spPr>
+          <a:xfrm>
+            <a:off x="6096000" y="685800"/>
+            <a:ext cx="5200650" cy="215444"/>
+          </a:xfrm>
+          <a:prstGeom prst="rect">
+            <a:avLst/>
+          </a:prstGeom>
+        </p:spPr>
+        <p:txBody>
+          <a:bodyPr wrap="square" lIns="0" tIns="0" rIns="0" bIns="0">
+            <a:spAutoFit/>
+          </a:bodyPr>
+          <a:lstStyle>
+            <a:lvl1pPr marL="0">
+              <a:defRPr>
+                <a:latin typeface="+mn-lt"/>
+                <a:ea typeface="+mn-ea"/>
+                <a:cs typeface="+mn-cs"/>
+              </a:defRPr>
+            </a:lvl1pPr>
+            <a:lvl2pPr marL="457200">
+              <a:defRPr>
+                <a:latin typeface="+mn-lt"/>
+                <a:ea typeface="+mn-ea"/>
+                <a:cs typeface="+mn-cs"/>
+              </a:defRPr>
+            </a:lvl2pPr>
+            <a:lvl3pPr marL="914400">
+              <a:defRPr>
+                <a:latin typeface="+mn-lt"/>
+                <a:ea typeface="+mn-ea"/>
+                <a:cs typeface="+mn-cs"/>
+              </a:defRPr>
+            </a:lvl3pPr>
+            <a:lvl4pPr marL="1371600">
+              <a:defRPr>
+                <a:latin typeface="+mn-lt"/>
+                <a:ea typeface="+mn-ea"/>
+                <a:cs typeface="+mn-cs"/>
+              </a:defRPr>
+            </a:lvl4pPr>
+            <a:lvl5pPr marL="1828800">
+              <a:defRPr>
+                <a:latin typeface="+mn-lt"/>
+                <a:ea typeface="+mn-ea"/>
+                <a:cs typeface="+mn-cs"/>
+              </a:defRPr>
+            </a:lvl5pPr>
+            <a:lvl6pPr marL="2286000">
+              <a:defRPr>
+                <a:latin typeface="+mn-lt"/>
+                <a:ea typeface="+mn-ea"/>
+                <a:cs typeface="+mn-cs"/>
+              </a:defRPr>
+            </a:lvl6pPr>
+            <a:lvl7pPr marL="2743200">
+              <a:defRPr>
+                <a:latin typeface="+mn-lt"/>
+                <a:ea typeface="+mn-ea"/>
+                <a:cs typeface="+mn-cs"/>
+              </a:defRPr>
+            </a:lvl7pPr>
+            <a:lvl8pPr marL="3200400">
+              <a:defRPr>
+                <a:latin typeface="+mn-lt"/>
+                <a:ea typeface="+mn-ea"/>
+                <a:cs typeface="+mn-cs"/>
+              </a:defRPr>
+            </a:lvl8pPr>
+            <a:lvl9pPr marL="3657600">
+              <a:defRPr>
+                <a:latin typeface="+mn-lt"/>
+                <a:ea typeface="+mn-ea"/>
+                <a:cs typeface="+mn-cs"/>
+              </a:defRPr>
+            </a:lvl9pPr>
+          </a:lstStyle>
+          <a:p>
+            <a:pPr algn="just"/>
+            <a:r>
+              <a:rPr lang="en-US" sz="1400" dirty="0">
+                <a:latin typeface="Arial" panose="020B0604020202020204" pitchFamily="34" charset="0"/>
+                <a:cs typeface="Arial" panose="020B0604020202020204" pitchFamily="34" charset="0"/>
+              </a:rPr>
+              <a:t>Con la </a:t>
+            </a:r>
+            <a:r>
+              <a:rPr lang="en-US" sz="1400" dirty="0" err="1">
+                <a:latin typeface="Arial" panose="020B0604020202020204" pitchFamily="34" charset="0"/>
+                <a:cs typeface="Arial" panose="020B0604020202020204" pitchFamily="34" charset="0"/>
+              </a:rPr>
+              <a:t>guia</a:t>
+            </a:r>
+            <a:r>
+              <a:rPr lang="en-US" sz="1400" dirty="0">
+                <a:latin typeface="Arial" panose="020B0604020202020204" pitchFamily="34" charset="0"/>
+                <a:cs typeface="Arial" panose="020B0604020202020204" pitchFamily="34" charset="0"/>
+              </a:rPr>
+              <a:t> deep </a:t>
+            </a:r>
+            <a:r>
+              <a:rPr lang="en-US" sz="1400" dirty="0" err="1">
+                <a:latin typeface="Arial" panose="020B0604020202020204" pitchFamily="34" charset="0"/>
+                <a:cs typeface="Arial" panose="020B0604020202020204" pitchFamily="34" charset="0"/>
+              </a:rPr>
+              <a:t>los</a:t>
+            </a:r>
+            <a:r>
+              <a:rPr lang="en-US" sz="1400" dirty="0">
+                <a:latin typeface="Arial" panose="020B0604020202020204" pitchFamily="34" charset="0"/>
+                <a:cs typeface="Arial" panose="020B0604020202020204" pitchFamily="34" charset="0"/>
+              </a:rPr>
+              <a:t> </a:t>
+            </a:r>
+            <a:r>
+              <a:rPr lang="en-US" sz="1400" dirty="0" err="1">
+                <a:latin typeface="Arial" panose="020B0604020202020204" pitchFamily="34" charset="0"/>
+                <a:cs typeface="Arial" panose="020B0604020202020204" pitchFamily="34" charset="0"/>
+              </a:rPr>
+              <a:t>modos</a:t>
+            </a:r>
+            <a:r>
+              <a:rPr lang="en-US" sz="1400" dirty="0">
+                <a:latin typeface="Arial" panose="020B0604020202020204" pitchFamily="34" charset="0"/>
+                <a:cs typeface="Arial" panose="020B0604020202020204" pitchFamily="34" charset="0"/>
+              </a:rPr>
+              <a:t> 0 y 2 son TE y </a:t>
+            </a:r>
+            <a:r>
+              <a:rPr lang="en-US" sz="1400" dirty="0" err="1">
+                <a:latin typeface="Arial" panose="020B0604020202020204" pitchFamily="34" charset="0"/>
+                <a:cs typeface="Arial" panose="020B0604020202020204" pitchFamily="34" charset="0"/>
+              </a:rPr>
+              <a:t>el</a:t>
+            </a:r>
+            <a:r>
+              <a:rPr lang="en-US" sz="1400" dirty="0">
+                <a:latin typeface="Arial" panose="020B0604020202020204" pitchFamily="34" charset="0"/>
+                <a:cs typeface="Arial" panose="020B0604020202020204" pitchFamily="34" charset="0"/>
+              </a:rPr>
+              <a:t> 1 y 3 son TM.</a:t>
+            </a:r>
+            <a:endParaRPr lang="es-ES" sz="1400" kern="0" dirty="0">
+              <a:solidFill>
+                <a:sysClr val="windowText" lastClr="000000"/>
+              </a:solidFill>
+            </a:endParaRPr>
+          </a:p>
+        </p:txBody>
+      </p:sp>
+      <p:pic>
+        <p:nvPicPr>
+          <p:cNvPr id="10" name="Imagen 9" descr="Texto&#10;&#10;El contenido generado por IA puede ser incorrecto.">
+            <a:extLst>
+              <a:ext uri="{FF2B5EF4-FFF2-40B4-BE49-F238E27FC236}">
+                <a16:creationId xmlns:a16="http://schemas.microsoft.com/office/drawing/2014/main" id="{073763D2-9E89-0921-5D36-E754F3F4B585}"/>
+              </a:ext>
+            </a:extLst>
+          </p:cNvPr>
+          <p:cNvPicPr>
+            <a:picLocks noChangeAspect="1"/>
+          </p:cNvPicPr>
+          <p:nvPr/>
+        </p:nvPicPr>
+        <p:blipFill>
+          <a:blip r:embed="rId3"/>
+          <a:stretch>
+            <a:fillRect/>
+          </a:stretch>
+        </p:blipFill>
+        <p:spPr>
+          <a:xfrm>
+            <a:off x="6096000" y="1199514"/>
+            <a:ext cx="4110409" cy="2573601"/>
+          </a:xfrm>
+          <a:prstGeom prst="rect">
+            <a:avLst/>
+          </a:prstGeom>
+        </p:spPr>
+      </p:pic>
+      <p:sp>
+        <p:nvSpPr>
+          <p:cNvPr id="13" name="Marcador de texto 2">
+            <a:extLst>
+              <a:ext uri="{FF2B5EF4-FFF2-40B4-BE49-F238E27FC236}">
+                <a16:creationId xmlns:a16="http://schemas.microsoft.com/office/drawing/2014/main" id="{067A748D-6BA9-60B0-DFF2-EC88EBA606B0}"/>
+              </a:ext>
+            </a:extLst>
+          </p:cNvPr>
+          <p:cNvSpPr txBox="1">
+            <a:spLocks/>
+          </p:cNvSpPr>
+          <p:nvPr/>
+        </p:nvSpPr>
+        <p:spPr>
+          <a:xfrm>
+            <a:off x="609600" y="4114800"/>
+            <a:ext cx="9982200" cy="1508105"/>
+          </a:xfrm>
+          <a:prstGeom prst="rect">
+            <a:avLst/>
+          </a:prstGeom>
+        </p:spPr>
+        <p:txBody>
+          <a:bodyPr wrap="square" lIns="0" tIns="0" rIns="0" bIns="0">
+            <a:spAutoFit/>
+          </a:bodyPr>
+          <a:lstStyle>
+            <a:lvl1pPr marL="0">
+              <a:defRPr>
+                <a:latin typeface="+mn-lt"/>
+                <a:ea typeface="+mn-ea"/>
+                <a:cs typeface="+mn-cs"/>
+              </a:defRPr>
+            </a:lvl1pPr>
+            <a:lvl2pPr marL="457200">
+              <a:defRPr>
+                <a:latin typeface="+mn-lt"/>
+                <a:ea typeface="+mn-ea"/>
+                <a:cs typeface="+mn-cs"/>
+              </a:defRPr>
+            </a:lvl2pPr>
+            <a:lvl3pPr marL="914400">
+              <a:defRPr>
+                <a:latin typeface="+mn-lt"/>
+                <a:ea typeface="+mn-ea"/>
+                <a:cs typeface="+mn-cs"/>
+              </a:defRPr>
+            </a:lvl3pPr>
+            <a:lvl4pPr marL="1371600">
+              <a:defRPr>
+                <a:latin typeface="+mn-lt"/>
+                <a:ea typeface="+mn-ea"/>
+                <a:cs typeface="+mn-cs"/>
+              </a:defRPr>
+            </a:lvl4pPr>
+            <a:lvl5pPr marL="1828800">
+              <a:defRPr>
+                <a:latin typeface="+mn-lt"/>
+                <a:ea typeface="+mn-ea"/>
+                <a:cs typeface="+mn-cs"/>
+              </a:defRPr>
+            </a:lvl5pPr>
+            <a:lvl6pPr marL="2286000">
+              <a:defRPr>
+                <a:latin typeface="+mn-lt"/>
+                <a:ea typeface="+mn-ea"/>
+                <a:cs typeface="+mn-cs"/>
+              </a:defRPr>
+            </a:lvl6pPr>
+            <a:lvl7pPr marL="2743200">
+              <a:defRPr>
+                <a:latin typeface="+mn-lt"/>
+                <a:ea typeface="+mn-ea"/>
+                <a:cs typeface="+mn-cs"/>
+              </a:defRPr>
+            </a:lvl7pPr>
+            <a:lvl8pPr marL="3200400">
+              <a:defRPr>
+                <a:latin typeface="+mn-lt"/>
+                <a:ea typeface="+mn-ea"/>
+                <a:cs typeface="+mn-cs"/>
+              </a:defRPr>
+            </a:lvl8pPr>
+            <a:lvl9pPr marL="3657600">
+              <a:defRPr>
+                <a:latin typeface="+mn-lt"/>
+                <a:ea typeface="+mn-ea"/>
+                <a:cs typeface="+mn-cs"/>
+              </a:defRPr>
+            </a:lvl9pPr>
+          </a:lstStyle>
+          <a:p>
+            <a:pPr algn="just"/>
+            <a:r>
+              <a:rPr lang="en-US" sz="1400" dirty="0">
+                <a:latin typeface="Arial" panose="020B0604020202020204" pitchFamily="34" charset="0"/>
+                <a:cs typeface="Arial" panose="020B0604020202020204" pitchFamily="34" charset="0"/>
+              </a:rPr>
+              <a:t>El </a:t>
+            </a:r>
+            <a:r>
+              <a:rPr lang="en-US" sz="1400" dirty="0" err="1">
+                <a:latin typeface="Arial" panose="020B0604020202020204" pitchFamily="34" charset="0"/>
+                <a:cs typeface="Arial" panose="020B0604020202020204" pitchFamily="34" charset="0"/>
+              </a:rPr>
+              <a:t>indice</a:t>
+            </a:r>
+            <a:r>
+              <a:rPr lang="en-US" sz="1400" dirty="0">
+                <a:latin typeface="Arial" panose="020B0604020202020204" pitchFamily="34" charset="0"/>
+                <a:cs typeface="Arial" panose="020B0604020202020204" pitchFamily="34" charset="0"/>
+              </a:rPr>
+              <a:t> </a:t>
+            </a:r>
+            <a:r>
+              <a:rPr lang="en-US" sz="1400" dirty="0" err="1">
+                <a:latin typeface="Arial" panose="020B0604020202020204" pitchFamily="34" charset="0"/>
+                <a:cs typeface="Arial" panose="020B0604020202020204" pitchFamily="34" charset="0"/>
+              </a:rPr>
+              <a:t>efectivo</a:t>
+            </a:r>
+            <a:r>
+              <a:rPr lang="en-US" sz="1400" dirty="0">
+                <a:latin typeface="Arial" panose="020B0604020202020204" pitchFamily="34" charset="0"/>
+                <a:cs typeface="Arial" panose="020B0604020202020204" pitchFamily="34" charset="0"/>
+              </a:rPr>
+              <a:t> no es </a:t>
+            </a:r>
+            <a:r>
+              <a:rPr lang="en-US" sz="1400" dirty="0" err="1">
+                <a:latin typeface="Arial" panose="020B0604020202020204" pitchFamily="34" charset="0"/>
+                <a:cs typeface="Arial" panose="020B0604020202020204" pitchFamily="34" charset="0"/>
+              </a:rPr>
+              <a:t>constante</a:t>
+            </a:r>
+            <a:r>
+              <a:rPr lang="en-US" sz="1400" dirty="0">
+                <a:latin typeface="Arial" panose="020B0604020202020204" pitchFamily="34" charset="0"/>
+                <a:cs typeface="Arial" panose="020B0604020202020204" pitchFamily="34" charset="0"/>
+              </a:rPr>
+              <a:t> y </a:t>
+            </a:r>
+            <a:r>
+              <a:rPr lang="en-US" sz="1400" dirty="0" err="1">
+                <a:latin typeface="Arial" panose="020B0604020202020204" pitchFamily="34" charset="0"/>
+                <a:cs typeface="Arial" panose="020B0604020202020204" pitchFamily="34" charset="0"/>
+              </a:rPr>
+              <a:t>vamos</a:t>
+            </a:r>
+            <a:r>
+              <a:rPr lang="en-US" sz="1400" dirty="0">
+                <a:latin typeface="Arial" panose="020B0604020202020204" pitchFamily="34" charset="0"/>
+                <a:cs typeface="Arial" panose="020B0604020202020204" pitchFamily="34" charset="0"/>
+              </a:rPr>
+              <a:t> a </a:t>
+            </a:r>
+            <a:r>
+              <a:rPr lang="en-US" sz="1400" dirty="0" err="1">
+                <a:latin typeface="Arial" panose="020B0604020202020204" pitchFamily="34" charset="0"/>
+                <a:cs typeface="Arial" panose="020B0604020202020204" pitchFamily="34" charset="0"/>
+              </a:rPr>
+              <a:t>tener</a:t>
+            </a:r>
+            <a:r>
+              <a:rPr lang="en-US" sz="1400" dirty="0">
+                <a:latin typeface="Arial" panose="020B0604020202020204" pitchFamily="34" charset="0"/>
+                <a:cs typeface="Arial" panose="020B0604020202020204" pitchFamily="34" charset="0"/>
+              </a:rPr>
+              <a:t> </a:t>
+            </a:r>
+            <a:r>
+              <a:rPr lang="en-US" sz="1400" dirty="0" err="1">
+                <a:latin typeface="Arial" panose="020B0604020202020204" pitchFamily="34" charset="0"/>
+                <a:cs typeface="Arial" panose="020B0604020202020204" pitchFamily="34" charset="0"/>
+              </a:rPr>
+              <a:t>dependencia</a:t>
+            </a:r>
+            <a:r>
+              <a:rPr lang="en-US" sz="1400" dirty="0">
+                <a:latin typeface="Arial" panose="020B0604020202020204" pitchFamily="34" charset="0"/>
+                <a:cs typeface="Arial" panose="020B0604020202020204" pitchFamily="34" charset="0"/>
+              </a:rPr>
+              <a:t> con la </a:t>
+            </a:r>
+            <a:r>
+              <a:rPr lang="en-US" sz="1400" dirty="0" err="1">
+                <a:latin typeface="Arial" panose="020B0604020202020204" pitchFamily="34" charset="0"/>
+                <a:cs typeface="Arial" panose="020B0604020202020204" pitchFamily="34" charset="0"/>
+              </a:rPr>
+              <a:t>longitud</a:t>
+            </a:r>
+            <a:r>
+              <a:rPr lang="en-US" sz="1400" dirty="0">
+                <a:latin typeface="Arial" panose="020B0604020202020204" pitchFamily="34" charset="0"/>
+                <a:cs typeface="Arial" panose="020B0604020202020204" pitchFamily="34" charset="0"/>
+              </a:rPr>
+              <a:t> de </a:t>
+            </a:r>
+            <a:r>
+              <a:rPr lang="en-US" sz="1400" dirty="0" err="1">
+                <a:latin typeface="Arial" panose="020B0604020202020204" pitchFamily="34" charset="0"/>
+                <a:cs typeface="Arial" panose="020B0604020202020204" pitchFamily="34" charset="0"/>
+              </a:rPr>
+              <a:t>onda</a:t>
+            </a:r>
+            <a:r>
+              <a:rPr lang="en-US" sz="1400" dirty="0">
+                <a:latin typeface="Arial" panose="020B0604020202020204" pitchFamily="34" charset="0"/>
+                <a:cs typeface="Arial" panose="020B0604020202020204" pitchFamily="34" charset="0"/>
+              </a:rPr>
+              <a:t> del </a:t>
+            </a:r>
+            <a:r>
+              <a:rPr lang="en-US" sz="1400" dirty="0" err="1">
+                <a:latin typeface="Arial" panose="020B0604020202020204" pitchFamily="34" charset="0"/>
+                <a:cs typeface="Arial" panose="020B0604020202020204" pitchFamily="34" charset="0"/>
+              </a:rPr>
+              <a:t>dispositivo</a:t>
+            </a:r>
+            <a:r>
+              <a:rPr lang="en-US" sz="1400" dirty="0">
+                <a:latin typeface="Arial" panose="020B0604020202020204" pitchFamily="34" charset="0"/>
+                <a:cs typeface="Arial" panose="020B0604020202020204" pitchFamily="34" charset="0"/>
+              </a:rPr>
+              <a:t>. </a:t>
+            </a:r>
+          </a:p>
+          <a:p>
+            <a:pPr algn="just"/>
+            <a:endParaRPr lang="en-US" sz="1400" dirty="0">
+              <a:latin typeface="Arial" panose="020B0604020202020204" pitchFamily="34" charset="0"/>
+              <a:cs typeface="Arial" panose="020B0604020202020204" pitchFamily="34" charset="0"/>
+            </a:endParaRPr>
+          </a:p>
+          <a:p>
+            <a:pPr algn="just"/>
+            <a:r>
+              <a:rPr lang="en-US" sz="1400" dirty="0" err="1">
+                <a:latin typeface="Arial" panose="020B0604020202020204" pitchFamily="34" charset="0"/>
+                <a:cs typeface="Arial" panose="020B0604020202020204" pitchFamily="34" charset="0"/>
+              </a:rPr>
+              <a:t>Respecto</a:t>
+            </a:r>
+            <a:r>
+              <a:rPr lang="en-US" sz="1400" dirty="0">
+                <a:latin typeface="Arial" panose="020B0604020202020204" pitchFamily="34" charset="0"/>
+                <a:cs typeface="Arial" panose="020B0604020202020204" pitchFamily="34" charset="0"/>
+              </a:rPr>
+              <a:t> al </a:t>
+            </a:r>
+            <a:r>
+              <a:rPr lang="en-US" sz="1400" dirty="0" err="1">
+                <a:latin typeface="Arial" panose="020B0604020202020204" pitchFamily="34" charset="0"/>
+                <a:cs typeface="Arial" panose="020B0604020202020204" pitchFamily="34" charset="0"/>
+              </a:rPr>
+              <a:t>confinamiento</a:t>
+            </a:r>
+            <a:r>
+              <a:rPr lang="en-US" sz="1400" dirty="0">
+                <a:latin typeface="Arial" panose="020B0604020202020204" pitchFamily="34" charset="0"/>
+                <a:cs typeface="Arial" panose="020B0604020202020204" pitchFamily="34" charset="0"/>
+              </a:rPr>
+              <a:t> de </a:t>
+            </a:r>
+            <a:r>
+              <a:rPr lang="en-US" sz="1400" dirty="0" err="1">
+                <a:latin typeface="Arial" panose="020B0604020202020204" pitchFamily="34" charset="0"/>
+                <a:cs typeface="Arial" panose="020B0604020202020204" pitchFamily="34" charset="0"/>
+              </a:rPr>
+              <a:t>esta</a:t>
+            </a:r>
+            <a:r>
+              <a:rPr lang="en-US" sz="1400" dirty="0">
+                <a:latin typeface="Arial" panose="020B0604020202020204" pitchFamily="34" charset="0"/>
+                <a:cs typeface="Arial" panose="020B0604020202020204" pitchFamily="34" charset="0"/>
+              </a:rPr>
+              <a:t> </a:t>
+            </a:r>
+            <a:r>
+              <a:rPr lang="en-US" sz="1400" dirty="0" err="1">
+                <a:latin typeface="Arial" panose="020B0604020202020204" pitchFamily="34" charset="0"/>
+                <a:cs typeface="Arial" panose="020B0604020202020204" pitchFamily="34" charset="0"/>
+              </a:rPr>
+              <a:t>guía</a:t>
+            </a:r>
+            <a:r>
+              <a:rPr lang="en-US" sz="1400" dirty="0">
+                <a:latin typeface="Arial" panose="020B0604020202020204" pitchFamily="34" charset="0"/>
+                <a:cs typeface="Arial" panose="020B0604020202020204" pitchFamily="34" charset="0"/>
+              </a:rPr>
+              <a:t>, </a:t>
+            </a:r>
+            <a:r>
+              <a:rPr lang="en-US" sz="1400" dirty="0" err="1">
+                <a:latin typeface="Arial" panose="020B0604020202020204" pitchFamily="34" charset="0"/>
+                <a:cs typeface="Arial" panose="020B0604020202020204" pitchFamily="34" charset="0"/>
+              </a:rPr>
+              <a:t>los</a:t>
+            </a:r>
+            <a:r>
+              <a:rPr lang="en-US" sz="1400" dirty="0">
+                <a:latin typeface="Arial" panose="020B0604020202020204" pitchFamily="34" charset="0"/>
+                <a:cs typeface="Arial" panose="020B0604020202020204" pitchFamily="34" charset="0"/>
+              </a:rPr>
+              <a:t> </a:t>
+            </a:r>
+            <a:r>
+              <a:rPr lang="en-US" sz="1400" dirty="0" err="1">
+                <a:latin typeface="Arial" panose="020B0604020202020204" pitchFamily="34" charset="0"/>
+                <a:cs typeface="Arial" panose="020B0604020202020204" pitchFamily="34" charset="0"/>
+              </a:rPr>
+              <a:t>modos</a:t>
+            </a:r>
+            <a:r>
+              <a:rPr lang="en-US" sz="1400" dirty="0">
+                <a:latin typeface="Arial" panose="020B0604020202020204" pitchFamily="34" charset="0"/>
+                <a:cs typeface="Arial" panose="020B0604020202020204" pitchFamily="34" charset="0"/>
+              </a:rPr>
+              <a:t> no </a:t>
+            </a:r>
+            <a:r>
+              <a:rPr lang="en-US" sz="1400" dirty="0" err="1">
+                <a:latin typeface="Arial" panose="020B0604020202020204" pitchFamily="34" charset="0"/>
+                <a:cs typeface="Arial" panose="020B0604020202020204" pitchFamily="34" charset="0"/>
+              </a:rPr>
+              <a:t>estan</a:t>
+            </a:r>
+            <a:r>
+              <a:rPr lang="en-US" sz="1400" dirty="0">
+                <a:latin typeface="Arial" panose="020B0604020202020204" pitchFamily="34" charset="0"/>
+                <a:cs typeface="Arial" panose="020B0604020202020204" pitchFamily="34" charset="0"/>
+              </a:rPr>
+              <a:t> </a:t>
+            </a:r>
+            <a:r>
+              <a:rPr lang="en-US" sz="1400" dirty="0" err="1">
+                <a:latin typeface="Arial" panose="020B0604020202020204" pitchFamily="34" charset="0"/>
+                <a:cs typeface="Arial" panose="020B0604020202020204" pitchFamily="34" charset="0"/>
+              </a:rPr>
+              <a:t>muy</a:t>
+            </a:r>
+            <a:r>
+              <a:rPr lang="en-US" sz="1400" dirty="0">
+                <a:latin typeface="Arial" panose="020B0604020202020204" pitchFamily="34" charset="0"/>
+                <a:cs typeface="Arial" panose="020B0604020202020204" pitchFamily="34" charset="0"/>
+              </a:rPr>
+              <a:t> bien </a:t>
+            </a:r>
+            <a:r>
+              <a:rPr lang="en-US" sz="1400" dirty="0" err="1">
+                <a:latin typeface="Arial" panose="020B0604020202020204" pitchFamily="34" charset="0"/>
+                <a:cs typeface="Arial" panose="020B0604020202020204" pitchFamily="34" charset="0"/>
+              </a:rPr>
+              <a:t>confinados</a:t>
+            </a:r>
+            <a:r>
+              <a:rPr lang="en-US" sz="1400" dirty="0">
+                <a:latin typeface="Arial" panose="020B0604020202020204" pitchFamily="34" charset="0"/>
+                <a:cs typeface="Arial" panose="020B0604020202020204" pitchFamily="34" charset="0"/>
+              </a:rPr>
+              <a:t> </a:t>
+            </a:r>
+            <a:r>
+              <a:rPr lang="en-US" sz="1400" dirty="0" err="1">
+                <a:latin typeface="Arial" panose="020B0604020202020204" pitchFamily="34" charset="0"/>
+                <a:cs typeface="Arial" panose="020B0604020202020204" pitchFamily="34" charset="0"/>
+              </a:rPr>
+              <a:t>porque</a:t>
+            </a:r>
+            <a:r>
+              <a:rPr lang="en-US" sz="1400" dirty="0">
+                <a:latin typeface="Arial" panose="020B0604020202020204" pitchFamily="34" charset="0"/>
+                <a:cs typeface="Arial" panose="020B0604020202020204" pitchFamily="34" charset="0"/>
+              </a:rPr>
+              <a:t> temenos un bajo </a:t>
+            </a:r>
+            <a:r>
+              <a:rPr lang="en-US" sz="1400" dirty="0" err="1">
+                <a:latin typeface="Arial" panose="020B0604020202020204" pitchFamily="34" charset="0"/>
+                <a:cs typeface="Arial" panose="020B0604020202020204" pitchFamily="34" charset="0"/>
+              </a:rPr>
+              <a:t>contraste</a:t>
+            </a:r>
+            <a:r>
+              <a:rPr lang="en-US" sz="1400" dirty="0">
+                <a:latin typeface="Arial" panose="020B0604020202020204" pitchFamily="34" charset="0"/>
+                <a:cs typeface="Arial" panose="020B0604020202020204" pitchFamily="34" charset="0"/>
+              </a:rPr>
+              <a:t> de indices entre </a:t>
+            </a:r>
+            <a:r>
+              <a:rPr lang="en-US" sz="1400" dirty="0" err="1">
+                <a:latin typeface="Arial" panose="020B0604020202020204" pitchFamily="34" charset="0"/>
+                <a:cs typeface="Arial" panose="020B0604020202020204" pitchFamily="34" charset="0"/>
+              </a:rPr>
+              <a:t>el</a:t>
+            </a:r>
+            <a:r>
+              <a:rPr lang="en-US" sz="1400" dirty="0">
+                <a:latin typeface="Arial" panose="020B0604020202020204" pitchFamily="34" charset="0"/>
+                <a:cs typeface="Arial" panose="020B0604020202020204" pitchFamily="34" charset="0"/>
+              </a:rPr>
+              <a:t> </a:t>
+            </a:r>
+            <a:r>
+              <a:rPr lang="en-US" sz="1400" dirty="0" err="1">
+                <a:latin typeface="Arial" panose="020B0604020202020204" pitchFamily="34" charset="0"/>
+                <a:cs typeface="Arial" panose="020B0604020202020204" pitchFamily="34" charset="0"/>
+              </a:rPr>
+              <a:t>nucleo</a:t>
+            </a:r>
+            <a:r>
+              <a:rPr lang="en-US" sz="1400" dirty="0">
+                <a:latin typeface="Arial" panose="020B0604020202020204" pitchFamily="34" charset="0"/>
+                <a:cs typeface="Arial" panose="020B0604020202020204" pitchFamily="34" charset="0"/>
+              </a:rPr>
+              <a:t> y </a:t>
+            </a:r>
+            <a:r>
+              <a:rPr lang="en-US" sz="1400" dirty="0" err="1">
+                <a:latin typeface="Arial" panose="020B0604020202020204" pitchFamily="34" charset="0"/>
+                <a:cs typeface="Arial" panose="020B0604020202020204" pitchFamily="34" charset="0"/>
+              </a:rPr>
+              <a:t>el</a:t>
+            </a:r>
+            <a:r>
+              <a:rPr lang="en-US" sz="1400" dirty="0">
+                <a:latin typeface="Arial" panose="020B0604020202020204" pitchFamily="34" charset="0"/>
+                <a:cs typeface="Arial" panose="020B0604020202020204" pitchFamily="34" charset="0"/>
+              </a:rPr>
+              <a:t> cladding </a:t>
+            </a:r>
+            <a:r>
+              <a:rPr lang="en-US" sz="1400" dirty="0" err="1">
+                <a:latin typeface="Arial" panose="020B0604020202020204" pitchFamily="34" charset="0"/>
+                <a:cs typeface="Arial" panose="020B0604020202020204" pitchFamily="34" charset="0"/>
+              </a:rPr>
+              <a:t>en</a:t>
+            </a:r>
+            <a:r>
+              <a:rPr lang="en-US" sz="1400" dirty="0">
+                <a:latin typeface="Arial" panose="020B0604020202020204" pitchFamily="34" charset="0"/>
+                <a:cs typeface="Arial" panose="020B0604020202020204" pitchFamily="34" charset="0"/>
+              </a:rPr>
+              <a:t> </a:t>
+            </a:r>
+            <a:r>
+              <a:rPr lang="en-US" sz="1400" dirty="0" err="1">
+                <a:latin typeface="Arial" panose="020B0604020202020204" pitchFamily="34" charset="0"/>
+                <a:cs typeface="Arial" panose="020B0604020202020204" pitchFamily="34" charset="0"/>
+              </a:rPr>
+              <a:t>los</a:t>
+            </a:r>
+            <a:r>
+              <a:rPr lang="en-US" sz="1400" dirty="0">
+                <a:latin typeface="Arial" panose="020B0604020202020204" pitchFamily="34" charset="0"/>
+                <a:cs typeface="Arial" panose="020B0604020202020204" pitchFamily="34" charset="0"/>
+              </a:rPr>
+              <a:t> dos </a:t>
+            </a:r>
+            <a:r>
+              <a:rPr lang="en-US" sz="1400" dirty="0" err="1">
+                <a:latin typeface="Arial" panose="020B0604020202020204" pitchFamily="34" charset="0"/>
+                <a:cs typeface="Arial" panose="020B0604020202020204" pitchFamily="34" charset="0"/>
+              </a:rPr>
+              <a:t>tipos</a:t>
+            </a:r>
+            <a:r>
+              <a:rPr lang="en-US" sz="1400" dirty="0">
+                <a:latin typeface="Arial" panose="020B0604020202020204" pitchFamily="34" charset="0"/>
+                <a:cs typeface="Arial" panose="020B0604020202020204" pitchFamily="34" charset="0"/>
+              </a:rPr>
+              <a:t> de </a:t>
+            </a:r>
+            <a:r>
+              <a:rPr lang="en-US" sz="1400" dirty="0" err="1">
+                <a:latin typeface="Arial" panose="020B0604020202020204" pitchFamily="34" charset="0"/>
+                <a:cs typeface="Arial" panose="020B0604020202020204" pitchFamily="34" charset="0"/>
+              </a:rPr>
+              <a:t>guia</a:t>
+            </a:r>
+            <a:r>
+              <a:rPr lang="en-US" sz="1400" dirty="0">
+                <a:latin typeface="Arial" panose="020B0604020202020204" pitchFamily="34" charset="0"/>
+                <a:cs typeface="Arial" panose="020B0604020202020204" pitchFamily="34" charset="0"/>
+              </a:rPr>
+              <a:t>. Se </a:t>
+            </a:r>
+            <a:r>
+              <a:rPr lang="en-US" sz="1400" dirty="0" err="1">
+                <a:latin typeface="Arial" panose="020B0604020202020204" pitchFamily="34" charset="0"/>
+                <a:cs typeface="Arial" panose="020B0604020202020204" pitchFamily="34" charset="0"/>
+              </a:rPr>
+              <a:t>observa</a:t>
+            </a:r>
+            <a:r>
+              <a:rPr lang="en-US" sz="1400" dirty="0">
+                <a:latin typeface="Arial" panose="020B0604020202020204" pitchFamily="34" charset="0"/>
+                <a:cs typeface="Arial" panose="020B0604020202020204" pitchFamily="34" charset="0"/>
+              </a:rPr>
+              <a:t> </a:t>
+            </a:r>
+            <a:r>
+              <a:rPr lang="en-US" sz="1400" dirty="0" err="1">
+                <a:latin typeface="Arial" panose="020B0604020202020204" pitchFamily="34" charset="0"/>
+                <a:cs typeface="Arial" panose="020B0604020202020204" pitchFamily="34" charset="0"/>
+              </a:rPr>
+              <a:t>que</a:t>
+            </a:r>
+            <a:r>
+              <a:rPr lang="en-US" sz="1400" dirty="0">
+                <a:latin typeface="Arial" panose="020B0604020202020204" pitchFamily="34" charset="0"/>
+                <a:cs typeface="Arial" panose="020B0604020202020204" pitchFamily="34" charset="0"/>
+              </a:rPr>
+              <a:t> </a:t>
+            </a:r>
+            <a:r>
+              <a:rPr lang="en-US" sz="1400" dirty="0" err="1">
+                <a:latin typeface="Arial" panose="020B0604020202020204" pitchFamily="34" charset="0"/>
+                <a:cs typeface="Arial" panose="020B0604020202020204" pitchFamily="34" charset="0"/>
+              </a:rPr>
+              <a:t>el</a:t>
+            </a:r>
+            <a:r>
+              <a:rPr lang="en-US" sz="1400" dirty="0">
+                <a:latin typeface="Arial" panose="020B0604020202020204" pitchFamily="34" charset="0"/>
+                <a:cs typeface="Arial" panose="020B0604020202020204" pitchFamily="34" charset="0"/>
+              </a:rPr>
+              <a:t> </a:t>
+            </a:r>
+            <a:r>
+              <a:rPr lang="en-US" sz="1400" dirty="0" err="1">
+                <a:latin typeface="Arial" panose="020B0604020202020204" pitchFamily="34" charset="0"/>
+                <a:cs typeface="Arial" panose="020B0604020202020204" pitchFamily="34" charset="0"/>
+              </a:rPr>
+              <a:t>indice</a:t>
+            </a:r>
+            <a:r>
+              <a:rPr lang="en-US" sz="1400" dirty="0">
+                <a:latin typeface="Arial" panose="020B0604020202020204" pitchFamily="34" charset="0"/>
+                <a:cs typeface="Arial" panose="020B0604020202020204" pitchFamily="34" charset="0"/>
+              </a:rPr>
+              <a:t> </a:t>
+            </a:r>
+            <a:r>
+              <a:rPr lang="en-US" sz="1400" dirty="0" err="1">
+                <a:latin typeface="Arial" panose="020B0604020202020204" pitchFamily="34" charset="0"/>
+                <a:cs typeface="Arial" panose="020B0604020202020204" pitchFamily="34" charset="0"/>
+              </a:rPr>
+              <a:t>efectivo</a:t>
+            </a:r>
+            <a:r>
+              <a:rPr lang="en-US" sz="1400" dirty="0">
+                <a:latin typeface="Arial" panose="020B0604020202020204" pitchFamily="34" charset="0"/>
+                <a:cs typeface="Arial" panose="020B0604020202020204" pitchFamily="34" charset="0"/>
+              </a:rPr>
+              <a:t> de </a:t>
+            </a:r>
+            <a:r>
+              <a:rPr lang="en-US" sz="1400" dirty="0" err="1">
+                <a:latin typeface="Arial" panose="020B0604020202020204" pitchFamily="34" charset="0"/>
+                <a:cs typeface="Arial" panose="020B0604020202020204" pitchFamily="34" charset="0"/>
+              </a:rPr>
+              <a:t>los</a:t>
+            </a:r>
+            <a:r>
+              <a:rPr lang="en-US" sz="1400" dirty="0">
+                <a:latin typeface="Arial" panose="020B0604020202020204" pitchFamily="34" charset="0"/>
+                <a:cs typeface="Arial" panose="020B0604020202020204" pitchFamily="34" charset="0"/>
+              </a:rPr>
+              <a:t> </a:t>
+            </a:r>
+            <a:r>
+              <a:rPr lang="en-US" sz="1400" dirty="0" err="1">
+                <a:latin typeface="Arial" panose="020B0604020202020204" pitchFamily="34" charset="0"/>
+                <a:cs typeface="Arial" panose="020B0604020202020204" pitchFamily="34" charset="0"/>
+              </a:rPr>
+              <a:t>modos</a:t>
+            </a:r>
+            <a:r>
+              <a:rPr lang="en-US" sz="1400" dirty="0">
+                <a:latin typeface="Arial" panose="020B0604020202020204" pitchFamily="34" charset="0"/>
+                <a:cs typeface="Arial" panose="020B0604020202020204" pitchFamily="34" charset="0"/>
+              </a:rPr>
+              <a:t> de </a:t>
+            </a:r>
+            <a:r>
+              <a:rPr lang="en-US" sz="1400" dirty="0" err="1">
+                <a:latin typeface="Arial" panose="020B0604020202020204" pitchFamily="34" charset="0"/>
+                <a:cs typeface="Arial" panose="020B0604020202020204" pitchFamily="34" charset="0"/>
+              </a:rPr>
+              <a:t>cada</a:t>
+            </a:r>
+            <a:r>
+              <a:rPr lang="en-US" sz="1400" dirty="0">
+                <a:latin typeface="Arial" panose="020B0604020202020204" pitchFamily="34" charset="0"/>
+                <a:cs typeface="Arial" panose="020B0604020202020204" pitchFamily="34" charset="0"/>
+              </a:rPr>
+              <a:t> </a:t>
+            </a:r>
+            <a:r>
+              <a:rPr lang="en-US" sz="1400" dirty="0" err="1">
+                <a:latin typeface="Arial" panose="020B0604020202020204" pitchFamily="34" charset="0"/>
+                <a:cs typeface="Arial" panose="020B0604020202020204" pitchFamily="34" charset="0"/>
+              </a:rPr>
+              <a:t>una</a:t>
+            </a:r>
+            <a:r>
+              <a:rPr lang="en-US" sz="1400" dirty="0">
+                <a:latin typeface="Arial" panose="020B0604020202020204" pitchFamily="34" charset="0"/>
+                <a:cs typeface="Arial" panose="020B0604020202020204" pitchFamily="34" charset="0"/>
+              </a:rPr>
+              <a:t> de las </a:t>
+            </a:r>
+            <a:r>
+              <a:rPr lang="en-US" sz="1400" dirty="0" err="1">
+                <a:latin typeface="Arial" panose="020B0604020202020204" pitchFamily="34" charset="0"/>
+                <a:cs typeface="Arial" panose="020B0604020202020204" pitchFamily="34" charset="0"/>
+              </a:rPr>
+              <a:t>guias</a:t>
+            </a:r>
+            <a:r>
+              <a:rPr lang="en-US" sz="1400" dirty="0">
+                <a:latin typeface="Arial" panose="020B0604020202020204" pitchFamily="34" charset="0"/>
+                <a:cs typeface="Arial" panose="020B0604020202020204" pitchFamily="34" charset="0"/>
+              </a:rPr>
+              <a:t> son </a:t>
+            </a:r>
+            <a:r>
+              <a:rPr lang="en-US" sz="1400" dirty="0" err="1">
+                <a:latin typeface="Arial" panose="020B0604020202020204" pitchFamily="34" charset="0"/>
+                <a:cs typeface="Arial" panose="020B0604020202020204" pitchFamily="34" charset="0"/>
+              </a:rPr>
+              <a:t>valores</a:t>
+            </a:r>
+            <a:r>
+              <a:rPr lang="en-US" sz="1400" dirty="0">
+                <a:latin typeface="Arial" panose="020B0604020202020204" pitchFamily="34" charset="0"/>
+                <a:cs typeface="Arial" panose="020B0604020202020204" pitchFamily="34" charset="0"/>
+              </a:rPr>
+              <a:t> </a:t>
+            </a:r>
+            <a:r>
+              <a:rPr lang="en-US" sz="1400" dirty="0" err="1">
+                <a:latin typeface="Arial" panose="020B0604020202020204" pitchFamily="34" charset="0"/>
+                <a:cs typeface="Arial" panose="020B0604020202020204" pitchFamily="34" charset="0"/>
+              </a:rPr>
+              <a:t>cercanos</a:t>
+            </a:r>
+            <a:r>
+              <a:rPr lang="en-US" sz="1400" dirty="0">
+                <a:latin typeface="Arial" panose="020B0604020202020204" pitchFamily="34" charset="0"/>
+                <a:cs typeface="Arial" panose="020B0604020202020204" pitchFamily="34" charset="0"/>
+              </a:rPr>
+              <a:t> al </a:t>
+            </a:r>
+            <a:r>
+              <a:rPr lang="en-US" sz="1400" dirty="0" err="1">
+                <a:latin typeface="Arial" panose="020B0604020202020204" pitchFamily="34" charset="0"/>
+                <a:cs typeface="Arial" panose="020B0604020202020204" pitchFamily="34" charset="0"/>
+              </a:rPr>
+              <a:t>indice</a:t>
+            </a:r>
+            <a:r>
+              <a:rPr lang="en-US" sz="1400" dirty="0">
+                <a:latin typeface="Arial" panose="020B0604020202020204" pitchFamily="34" charset="0"/>
+                <a:cs typeface="Arial" panose="020B0604020202020204" pitchFamily="34" charset="0"/>
+              </a:rPr>
+              <a:t> del cladding (1.46). Como </a:t>
+            </a:r>
+            <a:r>
+              <a:rPr lang="en-US" sz="1400" dirty="0" err="1">
+                <a:latin typeface="Arial" panose="020B0604020202020204" pitchFamily="34" charset="0"/>
+                <a:cs typeface="Arial" panose="020B0604020202020204" pitchFamily="34" charset="0"/>
+              </a:rPr>
+              <a:t>el</a:t>
+            </a:r>
+            <a:r>
+              <a:rPr lang="en-US" sz="1400" dirty="0">
+                <a:latin typeface="Arial" panose="020B0604020202020204" pitchFamily="34" charset="0"/>
+                <a:cs typeface="Arial" panose="020B0604020202020204" pitchFamily="34" charset="0"/>
+              </a:rPr>
+              <a:t> </a:t>
+            </a:r>
+            <a:r>
+              <a:rPr lang="en-US" sz="1400" dirty="0" err="1">
+                <a:latin typeface="Arial" panose="020B0604020202020204" pitchFamily="34" charset="0"/>
+                <a:cs typeface="Arial" panose="020B0604020202020204" pitchFamily="34" charset="0"/>
+              </a:rPr>
+              <a:t>indice</a:t>
+            </a:r>
+            <a:r>
+              <a:rPr lang="en-US" sz="1400" dirty="0">
+                <a:latin typeface="Arial" panose="020B0604020202020204" pitchFamily="34" charset="0"/>
+                <a:cs typeface="Arial" panose="020B0604020202020204" pitchFamily="34" charset="0"/>
+              </a:rPr>
+              <a:t> </a:t>
+            </a:r>
+            <a:r>
+              <a:rPr lang="en-US" sz="1400" dirty="0" err="1">
+                <a:latin typeface="Arial" panose="020B0604020202020204" pitchFamily="34" charset="0"/>
+                <a:cs typeface="Arial" panose="020B0604020202020204" pitchFamily="34" charset="0"/>
+              </a:rPr>
+              <a:t>efectivo</a:t>
+            </a:r>
+            <a:r>
+              <a:rPr lang="en-US" sz="1400" dirty="0">
+                <a:latin typeface="Arial" panose="020B0604020202020204" pitchFamily="34" charset="0"/>
+                <a:cs typeface="Arial" panose="020B0604020202020204" pitchFamily="34" charset="0"/>
+              </a:rPr>
+              <a:t> se </a:t>
+            </a:r>
+            <a:r>
+              <a:rPr lang="en-US" sz="1400" dirty="0" err="1">
+                <a:latin typeface="Arial" panose="020B0604020202020204" pitchFamily="34" charset="0"/>
+                <a:cs typeface="Arial" panose="020B0604020202020204" pitchFamily="34" charset="0"/>
+              </a:rPr>
+              <a:t>aproxima</a:t>
+            </a:r>
+            <a:r>
+              <a:rPr lang="en-US" sz="1400" dirty="0">
+                <a:latin typeface="Arial" panose="020B0604020202020204" pitchFamily="34" charset="0"/>
+                <a:cs typeface="Arial" panose="020B0604020202020204" pitchFamily="34" charset="0"/>
+              </a:rPr>
+              <a:t> mas al del cladding </a:t>
+            </a:r>
+            <a:r>
+              <a:rPr lang="en-US" sz="1400" dirty="0" err="1">
+                <a:latin typeface="Arial" panose="020B0604020202020204" pitchFamily="34" charset="0"/>
+                <a:cs typeface="Arial" panose="020B0604020202020204" pitchFamily="34" charset="0"/>
+              </a:rPr>
+              <a:t>que</a:t>
+            </a:r>
+            <a:r>
+              <a:rPr lang="en-US" sz="1400" dirty="0">
+                <a:latin typeface="Arial" panose="020B0604020202020204" pitchFamily="34" charset="0"/>
+                <a:cs typeface="Arial" panose="020B0604020202020204" pitchFamily="34" charset="0"/>
+              </a:rPr>
+              <a:t> al del core no </a:t>
+            </a:r>
+            <a:r>
+              <a:rPr lang="en-US" sz="1400" dirty="0" err="1">
+                <a:latin typeface="Arial" panose="020B0604020202020204" pitchFamily="34" charset="0"/>
+                <a:cs typeface="Arial" panose="020B0604020202020204" pitchFamily="34" charset="0"/>
+              </a:rPr>
+              <a:t>tienen</a:t>
+            </a:r>
+            <a:r>
+              <a:rPr lang="en-US" sz="1400" dirty="0">
+                <a:latin typeface="Arial" panose="020B0604020202020204" pitchFamily="34" charset="0"/>
+                <a:cs typeface="Arial" panose="020B0604020202020204" pitchFamily="34" charset="0"/>
+              </a:rPr>
+              <a:t> un </a:t>
+            </a:r>
+            <a:r>
+              <a:rPr lang="en-US" sz="1400" dirty="0" err="1">
+                <a:latin typeface="Arial" panose="020B0604020202020204" pitchFamily="34" charset="0"/>
+                <a:cs typeface="Arial" panose="020B0604020202020204" pitchFamily="34" charset="0"/>
+              </a:rPr>
+              <a:t>buen</a:t>
+            </a:r>
+            <a:r>
+              <a:rPr lang="en-US" sz="1400" dirty="0">
+                <a:latin typeface="Arial" panose="020B0604020202020204" pitchFamily="34" charset="0"/>
+                <a:cs typeface="Arial" panose="020B0604020202020204" pitchFamily="34" charset="0"/>
+              </a:rPr>
+              <a:t> </a:t>
+            </a:r>
+            <a:r>
+              <a:rPr lang="en-US" sz="1400" dirty="0" err="1">
+                <a:latin typeface="Arial" panose="020B0604020202020204" pitchFamily="34" charset="0"/>
+                <a:cs typeface="Arial" panose="020B0604020202020204" pitchFamily="34" charset="0"/>
+              </a:rPr>
+              <a:t>confinamiento</a:t>
+            </a:r>
+            <a:r>
+              <a:rPr lang="en-US" sz="1400" dirty="0">
+                <a:latin typeface="Arial" panose="020B0604020202020204" pitchFamily="34" charset="0"/>
+                <a:cs typeface="Arial" panose="020B0604020202020204" pitchFamily="34" charset="0"/>
+              </a:rPr>
+              <a:t>.</a:t>
+            </a:r>
+          </a:p>
+          <a:p>
+            <a:endParaRPr lang="es-ES" sz="1400" kern="0" dirty="0">
+              <a:solidFill>
+                <a:sysClr val="windowText" lastClr="000000"/>
+              </a:solidFill>
+            </a:endParaRPr>
+          </a:p>
+        </p:txBody>
+      </p:sp>
+    </p:spTree>
+    <p:extLst>
+      <p:ext uri="{BB962C8B-B14F-4D97-AF65-F5344CB8AC3E}">
+        <p14:creationId xmlns:p14="http://schemas.microsoft.com/office/powerpoint/2010/main" val="444238847"/>
+      </p:ext>
+    </p:extLst>
+  </p:cSld>
+  <p:clrMapOvr>
+    <a:masterClrMapping/>
+  </p:clrMapOvr>
+</p:sld>
+</file>
+
+<file path=ppt/slides/slide7.xml><?xml version="1.0" encoding="utf-8"?>
+<p:sld xmlns:a="http://schemas.openxmlformats.org/drawingml/2006/main" xmlns:r="http://schemas.openxmlformats.org/officeDocument/2006/relationships" xmlns:p="http://schemas.openxmlformats.org/presentationml/2006/main">
+  <p:cSld>
+    <p:spTree>
+      <p:nvGrpSpPr>
+        <p:cNvPr id="1" name=""/>
+        <p:cNvGrpSpPr/>
+        <p:nvPr/>
+      </p:nvGrpSpPr>
+      <p:grpSpPr>
+        <a:xfrm>
+          <a:off x="0" y="0"/>
+          <a:ext cx="0" cy="0"/>
+          <a:chOff x="0" y="0"/>
+          <a:chExt cx="0" cy="0"/>
+        </a:xfrm>
+      </p:grpSpPr>
+      <p:sp>
+        <p:nvSpPr>
           <p:cNvPr id="3" name="object 3"/>
           <p:cNvSpPr/>
           <p:nvPr/>
@@ -7101,7 +9428,7 @@
           <a:p>
             <a:fld id="{B6F15528-21DE-4FAA-801E-634DDDAF4B2B}" type="slidenum">
               <a:rPr lang="es-ES" smtClean="0"/>
-              <a:t>5</a:t>
+              <a:t>7</a:t>
             </a:fld>
             <a:endParaRPr lang="es-ES"/>
           </a:p>
@@ -8029,23 +10356,6 @@
 </file>
 
 <file path=customXml/item1.xml><?xml version="1.0" encoding="utf-8"?>
-<p:properties xmlns:p="http://schemas.microsoft.com/office/2006/metadata/properties" xmlns:xsi="http://www.w3.org/2001/XMLSchema-instance" xmlns:pc="http://schemas.microsoft.com/office/infopath/2007/PartnerControls">
-  <documentManagement>
-    <_activity xmlns="512ad970-e211-4551-badd-1c89141866b5" xsi:nil="true"/>
-  </documentManagement>
-</p:properties>
-</file>
-
-<file path=customXml/item2.xml><?xml version="1.0" encoding="utf-8"?>
-<?mso-contentType ?>
-<FormTemplates xmlns="http://schemas.microsoft.com/sharepoint/v3/contenttype/forms">
-  <Display>DocumentLibraryForm</Display>
-  <Edit>DocumentLibraryForm</Edit>
-  <New>DocumentLibraryForm</New>
-</FormTemplates>
-</file>
-
-<file path=customXml/item3.xml><?xml version="1.0" encoding="utf-8"?>
 <ct:contentTypeSchema xmlns:ct="http://schemas.microsoft.com/office/2006/metadata/contentType" xmlns:ma="http://schemas.microsoft.com/office/2006/metadata/properties/metaAttributes" ct:_="" ma:_="" ma:contentTypeName="Documento" ma:contentTypeID="0x010100B4F9E81278D9EF4B93FEF4C39323CCC6" ma:contentTypeVersion="9" ma:contentTypeDescription="Crear nuevo documento." ma:contentTypeScope="" ma:versionID="d3230f1af0420652ab6bb9cc9a7d79bf">
   <xsd:schema xmlns:xsd="http://www.w3.org/2001/XMLSchema" xmlns:xs="http://www.w3.org/2001/XMLSchema" xmlns:p="http://schemas.microsoft.com/office/2006/metadata/properties" xmlns:ns3="512ad970-e211-4551-badd-1c89141866b5" xmlns:ns4="39b51ea6-d3c9-44a5-b163-cfe7ba19310b" targetNamespace="http://schemas.microsoft.com/office/2006/metadata/properties" ma:root="true" ma:fieldsID="f33886ecf8d1a5727ad2dd4cfd712005" ns3:_="" ns4:_="">
     <xsd:import namespace="512ad970-e211-4551-badd-1c89141866b5"/>
@@ -8240,32 +10550,24 @@
 </ct:contentTypeSchema>
 </file>
 
-<file path=customXml/itemProps1.xml><?xml version="1.0" encoding="utf-8"?>
-<ds:datastoreItem xmlns:ds="http://schemas.openxmlformats.org/officeDocument/2006/customXml" ds:itemID="{672770CA-3061-447B-B38E-0CE919B71026}">
-  <ds:schemaRefs>
-    <ds:schemaRef ds:uri="http://purl.org/dc/terms/"/>
-    <ds:schemaRef ds:uri="http://schemas.openxmlformats.org/package/2006/metadata/core-properties"/>
-    <ds:schemaRef ds:uri="512ad970-e211-4551-badd-1c89141866b5"/>
-    <ds:schemaRef ds:uri="http://purl.org/dc/dcmitype/"/>
-    <ds:schemaRef ds:uri="http://schemas.microsoft.com/office/2006/documentManagement/types"/>
-    <ds:schemaRef ds:uri="http://schemas.microsoft.com/office/infopath/2007/PartnerControls"/>
-    <ds:schemaRef ds:uri="39b51ea6-d3c9-44a5-b163-cfe7ba19310b"/>
-    <ds:schemaRef ds:uri="http://schemas.microsoft.com/office/2006/metadata/properties"/>
-    <ds:schemaRef ds:uri="http://www.w3.org/XML/1998/namespace"/>
-    <ds:schemaRef ds:uri="http://purl.org/dc/elements/1.1/"/>
-  </ds:schemaRefs>
-</ds:datastoreItem>
+<file path=customXml/item2.xml><?xml version="1.0" encoding="utf-8"?>
+<?mso-contentType ?>
+<FormTemplates xmlns="http://schemas.microsoft.com/sharepoint/v3/contenttype/forms">
+  <Display>DocumentLibraryForm</Display>
+  <Edit>DocumentLibraryForm</Edit>
+  <New>DocumentLibraryForm</New>
+</FormTemplates>
 </file>
 
-<file path=customXml/itemProps2.xml><?xml version="1.0" encoding="utf-8"?>
-<ds:datastoreItem xmlns:ds="http://schemas.openxmlformats.org/officeDocument/2006/customXml" ds:itemID="{ED6A1A82-244F-49B2-AE87-9E0E62E4BD07}">
-  <ds:schemaRefs>
-    <ds:schemaRef ds:uri="http://schemas.microsoft.com/sharepoint/v3/contenttype/forms"/>
-  </ds:schemaRefs>
-</ds:datastoreItem>
+<file path=customXml/item3.xml><?xml version="1.0" encoding="utf-8"?>
+<p:properties xmlns:p="http://schemas.microsoft.com/office/2006/metadata/properties" xmlns:xsi="http://www.w3.org/2001/XMLSchema-instance" xmlns:pc="http://schemas.microsoft.com/office/infopath/2007/PartnerControls">
+  <documentManagement>
+    <_activity xmlns="512ad970-e211-4551-badd-1c89141866b5" xsi:nil="true"/>
+  </documentManagement>
+</p:properties>
 </file>
 
-<file path=customXml/itemProps3.xml><?xml version="1.0" encoding="utf-8"?>
+<file path=customXml/itemProps1.xml><?xml version="1.0" encoding="utf-8"?>
 <ds:datastoreItem xmlns:ds="http://schemas.openxmlformats.org/officeDocument/2006/customXml" ds:itemID="{74D191D3-7CDB-438B-95CA-9F90BBE48D1D}">
   <ds:schemaRefs>
     <ds:schemaRef ds:uri="http://schemas.microsoft.com/office/2006/metadata/contentType"/>
@@ -8282,4 +10584,29 @@
     <ds:schemaRef ds:uri="http://schemas.microsoft.com/internal/obd"/>
   </ds:schemaRefs>
 </ds:datastoreItem>
+</file>
+
+<file path=customXml/itemProps2.xml><?xml version="1.0" encoding="utf-8"?>
+<ds:datastoreItem xmlns:ds="http://schemas.openxmlformats.org/officeDocument/2006/customXml" ds:itemID="{ED6A1A82-244F-49B2-AE87-9E0E62E4BD07}">
+  <ds:schemaRefs>
+    <ds:schemaRef ds:uri="http://schemas.microsoft.com/sharepoint/v3/contenttype/forms"/>
+  </ds:schemaRefs>
+</ds:datastoreItem>
+</file>
+
+<file path=customXml/itemProps3.xml><?xml version="1.0" encoding="utf-8"?>
+<ds:datastoreItem xmlns:ds="http://schemas.openxmlformats.org/officeDocument/2006/customXml" ds:itemID="{672770CA-3061-447B-B38E-0CE919B71026}">
+  <ds:schemaRefs>
+    <ds:schemaRef ds:uri="http://purl.org/dc/terms/"/>
+    <ds:schemaRef ds:uri="http://schemas.openxmlformats.org/package/2006/metadata/core-properties"/>
+    <ds:schemaRef ds:uri="512ad970-e211-4551-badd-1c89141866b5"/>
+    <ds:schemaRef ds:uri="http://purl.org/dc/dcmitype/"/>
+    <ds:schemaRef ds:uri="http://schemas.microsoft.com/office/2006/documentManagement/types"/>
+    <ds:schemaRef ds:uri="http://schemas.microsoft.com/office/infopath/2007/PartnerControls"/>
+    <ds:schemaRef ds:uri="39b51ea6-d3c9-44a5-b163-cfe7ba19310b"/>
+    <ds:schemaRef ds:uri="http://schemas.microsoft.com/office/2006/metadata/properties"/>
+    <ds:schemaRef ds:uri="http://www.w3.org/XML/1998/namespace"/>
+    <ds:schemaRef ds:uri="http://purl.org/dc/elements/1.1/"/>
+  </ds:schemaRefs>
+</ds:datastoreItem>
 </file>
</xml_diff>